<commit_message>
Include printable brochure and onsite template distribution in slides, PPTX, and website
</commit_message>
<xml_diff>
--- a/IBN_2026_Digital_Marketing_and_Platform_Strategy.pptx
+++ b/IBN_2026_Digital_Marketing_and_Platform_Strategy.pptx
@@ -14,6 +14,7 @@
     <p:sldId id="262" r:id="rId13"/>
     <p:sldId id="263" r:id="rId14"/>
     <p:sldId id="264" r:id="rId15"/>
+    <p:sldId id="265" r:id="rId16"/>
   </p:sldIdLst>
   <p:sldSz cx="12191695" cy="6858000" type="screen4x3"/>
   <p:notesSz cx="6858000" cy="9144000"/>
@@ -3343,7 +3344,7 @@
               </a:defRPr>
             </a:pPr>
             <a:r>
-              <a:t>Mobile App • Official Website • LinkedIn • Facebook • Instagram • WhatsApp • Email Newsletter</a:t>
+              <a:t>Mobile App • Website • LinkedIn • Facebook • Instagram • WhatsApp • Email • Print Collateral</a:t>
             </a:r>
             <a:br/>
             <a:r>
@@ -3441,7 +3442,615 @@
               </a:defRPr>
             </a:pPr>
             <a:r>
-              <a:t>A Multi-Touchpoint Promotion Strategy for Global Indian C-Suite Leadership</a:t>
+              <a:t>Digital Platform Strategy • Print Collateral • Onsite Event Distribution</a:t>
+            </a:r>
+          </a:p>
+        </p:txBody>
+      </p:sp>
+    </p:spTree>
+  </p:cSld>
+  <p:clrMapOvr>
+    <a:masterClrMapping/>
+  </p:clrMapOvr>
+</p:sld>
+</file>
+
+<file path=ppt/slides/slide10.xml><?xml version="1.0" encoding="utf-8"?>
+<p:sld xmlns:a="http://schemas.openxmlformats.org/drawingml/2006/main" xmlns:p="http://schemas.openxmlformats.org/presentationml/2006/main" xmlns:r="http://schemas.openxmlformats.org/officeDocument/2006/relationships">
+  <p:cSld>
+    <p:spTree>
+      <p:nvGrpSpPr>
+        <p:cNvPr id="1" name=""/>
+        <p:cNvGrpSpPr/>
+        <p:nvPr/>
+      </p:nvGrpSpPr>
+      <p:grpSpPr/>
+      <p:sp>
+        <p:nvSpPr>
+          <p:cNvPr id="2" name="Rectangle 1"/>
+          <p:cNvSpPr/>
+          <p:nvPr/>
+        </p:nvSpPr>
+        <p:spPr>
+          <a:xfrm>
+            <a:off x="0" y="0"/>
+            <a:ext cx="12191695" cy="6858000"/>
+          </a:xfrm>
+          <a:prstGeom prst="rect">
+            <a:avLst/>
+          </a:prstGeom>
+          <a:solidFill>
+            <a:srgbClr val="061226"/>
+          </a:solidFill>
+          <a:ln>
+            <a:noFill/>
+          </a:ln>
+        </p:spPr>
+        <p:style>
+          <a:lnRef idx="1">
+            <a:schemeClr val="accent1"/>
+          </a:lnRef>
+          <a:fillRef idx="3">
+            <a:schemeClr val="accent1"/>
+          </a:fillRef>
+          <a:effectRef idx="2">
+            <a:schemeClr val="accent1"/>
+          </a:effectRef>
+          <a:fontRef idx="minor">
+            <a:schemeClr val="lt1"/>
+          </a:fontRef>
+        </p:style>
+        <p:txBody>
+          <a:bodyPr rtlCol="0" anchor="ctr"/>
+          <a:lstStyle/>
+          <a:p>
+            <a:pPr algn="ctr"/>
+          </a:p>
+        </p:txBody>
+      </p:sp>
+      <p:sp>
+        <p:nvSpPr>
+          <p:cNvPr id="3" name="TextBox 2"/>
+          <p:cNvSpPr txBox="1"/>
+          <p:nvPr/>
+        </p:nvSpPr>
+        <p:spPr>
+          <a:xfrm>
+            <a:off x="731520" y="365760"/>
+            <a:ext cx="10698480" cy="1005840"/>
+          </a:xfrm>
+          <a:prstGeom prst="rect">
+            <a:avLst/>
+          </a:prstGeom>
+          <a:noFill/>
+        </p:spPr>
+        <p:txBody>
+          <a:bodyPr wrap="square" lIns="0" tIns="0" rIns="0" bIns="0">
+            <a:spAutoFit/>
+          </a:bodyPr>
+          <a:lstStyle/>
+          <a:p>
+            <a:pPr>
+              <a:spcAft>
+                <a:spcPts val="400"/>
+              </a:spcAft>
+              <a:defRPr sz="1100" b="1">
+                <a:solidFill>
+                  <a:srgbClr val="D4AF37"/>
+                </a:solidFill>
+                <a:latin typeface="Georgia"/>
+              </a:defRPr>
+            </a:pPr>
+            <a:r>
+              <a:t>MARKETING EXECUTION</a:t>
+            </a:r>
+          </a:p>
+          <a:p>
+            <a:pPr>
+              <a:defRPr sz="2500" b="1">
+                <a:solidFill>
+                  <a:srgbClr val="FFFFFF"/>
+                </a:solidFill>
+                <a:latin typeface="Calibri"/>
+              </a:defRPr>
+            </a:pPr>
+            <a:r>
+              <a:t>Integrated Multi-Channel Conversion Funnel</a:t>
+            </a:r>
+          </a:p>
+        </p:txBody>
+      </p:sp>
+      <p:sp>
+        <p:nvSpPr>
+          <p:cNvPr id="4" name="Rectangle 3"/>
+          <p:cNvSpPr/>
+          <p:nvPr/>
+        </p:nvSpPr>
+        <p:spPr>
+          <a:xfrm>
+            <a:off x="731520" y="1353312"/>
+            <a:ext cx="1645920" cy="36576"/>
+          </a:xfrm>
+          <a:prstGeom prst="rect">
+            <a:avLst/>
+          </a:prstGeom>
+          <a:solidFill>
+            <a:srgbClr val="D4AF37"/>
+          </a:solidFill>
+          <a:ln>
+            <a:noFill/>
+          </a:ln>
+        </p:spPr>
+        <p:style>
+          <a:lnRef idx="1">
+            <a:schemeClr val="accent1"/>
+          </a:lnRef>
+          <a:fillRef idx="3">
+            <a:schemeClr val="accent1"/>
+          </a:fillRef>
+          <a:effectRef idx="2">
+            <a:schemeClr val="accent1"/>
+          </a:effectRef>
+          <a:fontRef idx="minor">
+            <a:schemeClr val="lt1"/>
+          </a:fontRef>
+        </p:style>
+        <p:txBody>
+          <a:bodyPr rtlCol="0" anchor="ctr"/>
+          <a:lstStyle/>
+          <a:p>
+            <a:pPr algn="ctr"/>
+          </a:p>
+        </p:txBody>
+      </p:sp>
+      <p:sp>
+        <p:nvSpPr>
+          <p:cNvPr id="5" name="Rounded Rectangle 4"/>
+          <p:cNvSpPr/>
+          <p:nvPr/>
+        </p:nvSpPr>
+        <p:spPr>
+          <a:xfrm>
+            <a:off x="731520" y="1645920"/>
+            <a:ext cx="2587752" cy="4480560"/>
+          </a:xfrm>
+          <a:prstGeom prst="roundRect">
+            <a:avLst/>
+          </a:prstGeom>
+          <a:solidFill>
+            <a:srgbClr val="0C1C36"/>
+          </a:solidFill>
+          <a:ln w="12700">
+            <a:solidFill>
+              <a:srgbClr val="1E3A5F"/>
+            </a:solidFill>
+          </a:ln>
+        </p:spPr>
+        <p:style>
+          <a:lnRef idx="1">
+            <a:schemeClr val="accent1"/>
+          </a:lnRef>
+          <a:fillRef idx="3">
+            <a:schemeClr val="accent1"/>
+          </a:fillRef>
+          <a:effectRef idx="2">
+            <a:schemeClr val="accent1"/>
+          </a:effectRef>
+          <a:fontRef idx="minor">
+            <a:schemeClr val="lt1"/>
+          </a:fontRef>
+        </p:style>
+        <p:txBody>
+          <a:bodyPr rtlCol="0" anchor="ctr"/>
+          <a:lstStyle/>
+          <a:p>
+            <a:pPr algn="ctr"/>
+          </a:p>
+        </p:txBody>
+      </p:sp>
+      <p:sp>
+        <p:nvSpPr>
+          <p:cNvPr id="6" name="TextBox 5"/>
+          <p:cNvSpPr txBox="1"/>
+          <p:nvPr/>
+        </p:nvSpPr>
+        <p:spPr>
+          <a:xfrm>
+            <a:off x="914400" y="1920240"/>
+            <a:ext cx="2221992" cy="3931920"/>
+          </a:xfrm>
+          <a:prstGeom prst="rect">
+            <a:avLst/>
+          </a:prstGeom>
+          <a:noFill/>
+        </p:spPr>
+        <p:txBody>
+          <a:bodyPr wrap="square">
+            <a:spAutoFit/>
+          </a:bodyPr>
+          <a:lstStyle/>
+          <a:p>
+            <a:pPr>
+              <a:spcAft>
+                <a:spcPts val="400"/>
+              </a:spcAft>
+              <a:defRPr sz="1200" b="1">
+                <a:solidFill>
+                  <a:srgbClr val="D4AF37"/>
+                </a:solidFill>
+                <a:latin typeface="Georgia"/>
+              </a:defRPr>
+            </a:pPr>
+            <a:r>
+              <a:t>STAGE 1: AWARENESS</a:t>
+            </a:r>
+          </a:p>
+          <a:p>
+            <a:pPr>
+              <a:spcAft>
+                <a:spcPts val="1200"/>
+              </a:spcAft>
+              <a:defRPr sz="1600" b="1">
+                <a:solidFill>
+                  <a:srgbClr val="FFFFFF"/>
+                </a:solidFill>
+                <a:latin typeface="Calibri"/>
+              </a:defRPr>
+            </a:pPr>
+            <a:r>
+              <a:t>LinkedIn &amp; Media PR</a:t>
+            </a:r>
+          </a:p>
+          <a:p>
+            <a:pPr>
+              <a:defRPr sz="1200">
+                <a:solidFill>
+                  <a:srgbClr val="B4C3D7"/>
+                </a:solidFill>
+                <a:latin typeface="Calibri"/>
+              </a:defRPr>
+            </a:pPr>
+            <a:r>
+              <a:t>Thought leadership articles, official press releases, and executive announcements establishing global prestige.</a:t>
+            </a:r>
+          </a:p>
+        </p:txBody>
+      </p:sp>
+      <p:sp>
+        <p:nvSpPr>
+          <p:cNvPr id="7" name="Rounded Rectangle 6"/>
+          <p:cNvSpPr/>
+          <p:nvPr/>
+        </p:nvSpPr>
+        <p:spPr>
+          <a:xfrm>
+            <a:off x="3502152" y="1645920"/>
+            <a:ext cx="2587752" cy="4480560"/>
+          </a:xfrm>
+          <a:prstGeom prst="roundRect">
+            <a:avLst/>
+          </a:prstGeom>
+          <a:solidFill>
+            <a:srgbClr val="0C1C36"/>
+          </a:solidFill>
+          <a:ln w="12700">
+            <a:solidFill>
+              <a:srgbClr val="1E3A5F"/>
+            </a:solidFill>
+          </a:ln>
+        </p:spPr>
+        <p:style>
+          <a:lnRef idx="1">
+            <a:schemeClr val="accent1"/>
+          </a:lnRef>
+          <a:fillRef idx="3">
+            <a:schemeClr val="accent1"/>
+          </a:fillRef>
+          <a:effectRef idx="2">
+            <a:schemeClr val="accent1"/>
+          </a:effectRef>
+          <a:fontRef idx="minor">
+            <a:schemeClr val="lt1"/>
+          </a:fontRef>
+        </p:style>
+        <p:txBody>
+          <a:bodyPr rtlCol="0" anchor="ctr"/>
+          <a:lstStyle/>
+          <a:p>
+            <a:pPr algn="ctr"/>
+          </a:p>
+        </p:txBody>
+      </p:sp>
+      <p:sp>
+        <p:nvSpPr>
+          <p:cNvPr id="8" name="TextBox 7"/>
+          <p:cNvSpPr txBox="1"/>
+          <p:nvPr/>
+        </p:nvSpPr>
+        <p:spPr>
+          <a:xfrm>
+            <a:off x="3685032" y="1920240"/>
+            <a:ext cx="2221992" cy="3931920"/>
+          </a:xfrm>
+          <a:prstGeom prst="rect">
+            <a:avLst/>
+          </a:prstGeom>
+          <a:noFill/>
+        </p:spPr>
+        <p:txBody>
+          <a:bodyPr wrap="square">
+            <a:spAutoFit/>
+          </a:bodyPr>
+          <a:lstStyle/>
+          <a:p>
+            <a:pPr>
+              <a:spcAft>
+                <a:spcPts val="400"/>
+              </a:spcAft>
+              <a:defRPr sz="1200" b="1">
+                <a:solidFill>
+                  <a:srgbClr val="D4AF37"/>
+                </a:solidFill>
+                <a:latin typeface="Georgia"/>
+              </a:defRPr>
+            </a:pPr>
+            <a:r>
+              <a:t>STAGE 2: ENGAGEMENT</a:t>
+            </a:r>
+          </a:p>
+          <a:p>
+            <a:pPr>
+              <a:spcAft>
+                <a:spcPts val="1200"/>
+              </a:spcAft>
+              <a:defRPr sz="1600" b="1">
+                <a:solidFill>
+                  <a:srgbClr val="FFFFFF"/>
+                </a:solidFill>
+                <a:latin typeface="Calibri"/>
+              </a:defRPr>
+            </a:pPr>
+            <a:r>
+              <a:t>Instagram &amp; Facebook</a:t>
+            </a:r>
+          </a:p>
+          <a:p>
+            <a:pPr>
+              <a:defRPr sz="1200">
+                <a:solidFill>
+                  <a:srgbClr val="B4C3D7"/>
+                </a:solidFill>
+                <a:latin typeface="Calibri"/>
+              </a:defRPr>
+            </a:pPr>
+            <a:r>
+              <a:t>Cinematic video reels, carousel ads, and community discussions highlighting Oxford, Cambridge, and the Gala.</a:t>
+            </a:r>
+          </a:p>
+        </p:txBody>
+      </p:sp>
+      <p:sp>
+        <p:nvSpPr>
+          <p:cNvPr id="9" name="Rounded Rectangle 8"/>
+          <p:cNvSpPr/>
+          <p:nvPr/>
+        </p:nvSpPr>
+        <p:spPr>
+          <a:xfrm>
+            <a:off x="6272783" y="1645920"/>
+            <a:ext cx="2587752" cy="4480560"/>
+          </a:xfrm>
+          <a:prstGeom prst="roundRect">
+            <a:avLst/>
+          </a:prstGeom>
+          <a:solidFill>
+            <a:srgbClr val="0C1C36"/>
+          </a:solidFill>
+          <a:ln w="19050">
+            <a:solidFill>
+              <a:srgbClr val="D4AF37"/>
+            </a:solidFill>
+          </a:ln>
+        </p:spPr>
+        <p:style>
+          <a:lnRef idx="1">
+            <a:schemeClr val="accent1"/>
+          </a:lnRef>
+          <a:fillRef idx="3">
+            <a:schemeClr val="accent1"/>
+          </a:fillRef>
+          <a:effectRef idx="2">
+            <a:schemeClr val="accent1"/>
+          </a:effectRef>
+          <a:fontRef idx="minor">
+            <a:schemeClr val="lt1"/>
+          </a:fontRef>
+        </p:style>
+        <p:txBody>
+          <a:bodyPr rtlCol="0" anchor="ctr"/>
+          <a:lstStyle/>
+          <a:p>
+            <a:pPr algn="ctr"/>
+          </a:p>
+        </p:txBody>
+      </p:sp>
+      <p:sp>
+        <p:nvSpPr>
+          <p:cNvPr id="10" name="TextBox 9"/>
+          <p:cNvSpPr txBox="1"/>
+          <p:nvPr/>
+        </p:nvSpPr>
+        <p:spPr>
+          <a:xfrm>
+            <a:off x="6455663" y="1920240"/>
+            <a:ext cx="2221992" cy="3931920"/>
+          </a:xfrm>
+          <a:prstGeom prst="rect">
+            <a:avLst/>
+          </a:prstGeom>
+          <a:noFill/>
+        </p:spPr>
+        <p:txBody>
+          <a:bodyPr wrap="square">
+            <a:spAutoFit/>
+          </a:bodyPr>
+          <a:lstStyle/>
+          <a:p>
+            <a:pPr>
+              <a:spcAft>
+                <a:spcPts val="400"/>
+              </a:spcAft>
+              <a:defRPr sz="1200" b="1">
+                <a:solidFill>
+                  <a:srgbClr val="D4AF37"/>
+                </a:solidFill>
+                <a:latin typeface="Georgia"/>
+              </a:defRPr>
+            </a:pPr>
+            <a:r>
+              <a:t>STAGE 3: CONVERSION</a:t>
+            </a:r>
+          </a:p>
+          <a:p>
+            <a:pPr>
+              <a:spcAft>
+                <a:spcPts val="1200"/>
+              </a:spcAft>
+              <a:defRPr sz="1600" b="1">
+                <a:solidFill>
+                  <a:srgbClr val="FFFFFF"/>
+                </a:solidFill>
+                <a:latin typeface="Calibri"/>
+              </a:defRPr>
+            </a:pPr>
+            <a:r>
+              <a:t>Website &amp; WhatsApp</a:t>
+            </a:r>
+          </a:p>
+          <a:p>
+            <a:pPr>
+              <a:defRPr sz="1200">
+                <a:solidFill>
+                  <a:srgbClr val="B4C3D7"/>
+                </a:solidFill>
+                <a:latin typeface="Calibri"/>
+              </a:defRPr>
+            </a:pPr>
+            <a:r>
+              <a:t>Official vetting portal on the website (Tally embed) supported by 1-on-1 WhatsApp VIP concierge consultations.</a:t>
+            </a:r>
+          </a:p>
+        </p:txBody>
+      </p:sp>
+      <p:sp>
+        <p:nvSpPr>
+          <p:cNvPr id="11" name="Rounded Rectangle 10"/>
+          <p:cNvSpPr/>
+          <p:nvPr/>
+        </p:nvSpPr>
+        <p:spPr>
+          <a:xfrm>
+            <a:off x="9043416" y="1645920"/>
+            <a:ext cx="2587752" cy="4480560"/>
+          </a:xfrm>
+          <a:prstGeom prst="roundRect">
+            <a:avLst/>
+          </a:prstGeom>
+          <a:solidFill>
+            <a:srgbClr val="0C1C36"/>
+          </a:solidFill>
+          <a:ln w="12700">
+            <a:solidFill>
+              <a:srgbClr val="1E3A5F"/>
+            </a:solidFill>
+          </a:ln>
+        </p:spPr>
+        <p:style>
+          <a:lnRef idx="1">
+            <a:schemeClr val="accent1"/>
+          </a:lnRef>
+          <a:fillRef idx="3">
+            <a:schemeClr val="accent1"/>
+          </a:fillRef>
+          <a:effectRef idx="2">
+            <a:schemeClr val="accent1"/>
+          </a:effectRef>
+          <a:fontRef idx="minor">
+            <a:schemeClr val="lt1"/>
+          </a:fontRef>
+        </p:style>
+        <p:txBody>
+          <a:bodyPr rtlCol="0" anchor="ctr"/>
+          <a:lstStyle/>
+          <a:p>
+            <a:pPr algn="ctr"/>
+          </a:p>
+        </p:txBody>
+      </p:sp>
+      <p:sp>
+        <p:nvSpPr>
+          <p:cNvPr id="12" name="TextBox 11"/>
+          <p:cNvSpPr txBox="1"/>
+          <p:nvPr/>
+        </p:nvSpPr>
+        <p:spPr>
+          <a:xfrm>
+            <a:off x="9226296" y="1920240"/>
+            <a:ext cx="2221992" cy="3931920"/>
+          </a:xfrm>
+          <a:prstGeom prst="rect">
+            <a:avLst/>
+          </a:prstGeom>
+          <a:noFill/>
+        </p:spPr>
+        <p:txBody>
+          <a:bodyPr wrap="square">
+            <a:spAutoFit/>
+          </a:bodyPr>
+          <a:lstStyle/>
+          <a:p>
+            <a:pPr>
+              <a:spcAft>
+                <a:spcPts val="400"/>
+              </a:spcAft>
+              <a:defRPr sz="1200" b="1">
+                <a:solidFill>
+                  <a:srgbClr val="D4AF37"/>
+                </a:solidFill>
+                <a:latin typeface="Georgia"/>
+              </a:defRPr>
+            </a:pPr>
+            <a:r>
+              <a:t>STAGE 4: NURTURING</a:t>
+            </a:r>
+          </a:p>
+          <a:p>
+            <a:pPr>
+              <a:spcAft>
+                <a:spcPts val="1200"/>
+              </a:spcAft>
+              <a:defRPr sz="1600" b="1">
+                <a:solidFill>
+                  <a:srgbClr val="FFFFFF"/>
+                </a:solidFill>
+                <a:latin typeface="Calibri"/>
+              </a:defRPr>
+            </a:pPr>
+            <a:r>
+              <a:t>Email Drip &amp; Mobile App</a:t>
+            </a:r>
+          </a:p>
+          <a:p>
+            <a:pPr>
+              <a:defRPr sz="1200">
+                <a:solidFill>
+                  <a:srgbClr val="B4C3D7"/>
+                </a:solidFill>
+                <a:latin typeface="Calibri"/>
+              </a:defRPr>
+            </a:pPr>
+            <a:r>
+              <a:t>Targeted 4-stage email newsletters, security vetting confirmations, and digital mobile pass activation.</a:t>
             </a:r>
           </a:p>
         </p:txBody>
@@ -5305,7 +5914,7 @@
               </a:defRPr>
             </a:pPr>
             <a:r>
-              <a:t>MARKETING STRATEGY: LINKEDIN</a:t>
+              <a:t>EVENT COLLATERAL &amp; DISTRIBUTION</a:t>
             </a:r>
           </a:p>
           <a:p>
@@ -5318,7 +5927,7 @@
               </a:defRPr>
             </a:pPr>
             <a:r>
-              <a:t>LinkedIn Promotion: C-Suite Authority &amp; Thought Leadership</a:t>
+              <a:t>Printable Brochure &amp; Onsite Event Template Distribution</a:t>
             </a:r>
           </a:p>
         </p:txBody>
@@ -5375,7 +5984,7 @@
         <p:spPr>
           <a:xfrm>
             <a:off x="731520" y="1645920"/>
-            <a:ext cx="6583680" cy="4480560"/>
+            <a:ext cx="5193792" cy="2011680"/>
           </a:xfrm>
           <a:prstGeom prst="roundRect">
             <a:avLst/>
@@ -5411,16 +6020,40 @@
           </a:p>
         </p:txBody>
       </p:sp>
-      <p:sp>
-        <p:nvSpPr>
-          <p:cNvPr id="6" name="TextBox 5"/>
+      <p:pic>
+        <p:nvPicPr>
+          <p:cNvPr id="6" name="Picture 5" descr="icon_kit.png"/>
+          <p:cNvPicPr>
+            <a:picLocks noChangeAspect="1"/>
+          </p:cNvPicPr>
+          <p:nvPr/>
+        </p:nvPicPr>
+        <p:blipFill>
+          <a:blip r:embed="rId2"/>
+          <a:stretch>
+            <a:fillRect/>
+          </a:stretch>
+        </p:blipFill>
+        <p:spPr>
+          <a:xfrm>
+            <a:off x="960120" y="1874520"/>
+            <a:ext cx="594360" cy="594360"/>
+          </a:xfrm>
+          <a:prstGeom prst="rect">
+            <a:avLst/>
+          </a:prstGeom>
+        </p:spPr>
+      </p:pic>
+      <p:sp>
+        <p:nvSpPr>
+          <p:cNvPr id="7" name="TextBox 6"/>
           <p:cNvSpPr txBox="1"/>
           <p:nvPr/>
         </p:nvSpPr>
         <p:spPr>
           <a:xfrm>
-            <a:off x="1005840" y="1874519"/>
-            <a:ext cx="6035040" cy="4023360"/>
+            <a:off x="1691640" y="1828800"/>
+            <a:ext cx="4023360" cy="1645920"/>
           </a:xfrm>
           <a:prstGeom prst="rect">
             <a:avLst/>
@@ -5435,117 +6068,50 @@
           <a:p>
             <a:pPr>
               <a:spcAft>
-                <a:spcPts val="1000"/>
-              </a:spcAft>
-              <a:defRPr sz="1400" b="1">
-                <a:solidFill>
-                  <a:srgbClr val="D4AF37"/>
-                </a:solidFill>
-                <a:latin typeface="Georgia"/>
-              </a:defRPr>
-            </a:pPr>
-            <a:r>
-              <a:t>CORE MARKETING ENGINE: B2B &amp; EXECUTIVE VISIBILITY</a:t>
-            </a:r>
-          </a:p>
-          <a:p>
-            <a:pPr>
-              <a:spcAft>
                 <a:spcPts val="600"/>
               </a:spcAft>
+              <a:defRPr sz="1500" b="1">
+                <a:solidFill>
+                  <a:srgbClr val="D4AF37"/>
+                </a:solidFill>
+                <a:latin typeface="Georgia"/>
+              </a:defRPr>
+            </a:pPr>
+            <a:r>
+              <a:t>✦ Print-Ready Executive Brochure</a:t>
+            </a:r>
+          </a:p>
+          <a:p>
+            <a:pPr>
               <a:defRPr sz="1150">
                 <a:solidFill>
-                  <a:srgbClr val="FFFFFF"/>
+                  <a:srgbClr val="B4C3D7"/>
                 </a:solidFill>
                 <a:latin typeface="Calibri"/>
               </a:defRPr>
             </a:pPr>
             <a:r>
-              <a:t>• Institutional Announcement: Positioning the summit as an exclusive UK–India bilateral leadership summit held inside the British Parliament.</a:t>
-            </a:r>
-          </a:p>
-          <a:p>
-            <a:pPr>
-              <a:spcAft>
-                <a:spcPts val="600"/>
-              </a:spcAft>
-              <a:defRPr sz="1150">
-                <a:solidFill>
-                  <a:srgbClr val="FFFFFF"/>
-                </a:solidFill>
-                <a:latin typeface="Calibri"/>
-              </a:defRPr>
-            </a:pPr>
-            <a:r>
-              <a:t>• Founder &amp; President Voice: Personal executive notes from Velou Singaram and board members inviting peers to join the private corridor.</a:t>
-            </a:r>
-          </a:p>
-          <a:p>
-            <a:pPr>
-              <a:spcAft>
-                <a:spcPts val="600"/>
-              </a:spcAft>
-              <a:defRPr sz="1150">
-                <a:solidFill>
-                  <a:srgbClr val="FFFFFF"/>
-                </a:solidFill>
-                <a:latin typeface="Calibri"/>
-              </a:defRPr>
-            </a:pPr>
-            <a:r>
-              <a:t>• Academic Immersion Highlights: Spotlighting Oxford, Cambridge, and Imperial College London as catalysts for deep-tech and enterprise scaling.</a:t>
-            </a:r>
-          </a:p>
-          <a:p>
-            <a:pPr>
-              <a:spcAft>
-                <a:spcPts val="600"/>
-              </a:spcAft>
-              <a:defRPr sz="1150">
-                <a:solidFill>
-                  <a:srgbClr val="FFFFFF"/>
-                </a:solidFill>
-                <a:latin typeface="Calibri"/>
-              </a:defRPr>
-            </a:pPr>
-            <a:r>
-              <a:t>• Delegate &amp; Speaker Spotlights: Elegant digital badge creatives announcing vetted attendees: 'Proud to announce [Name] as an Executive Delegate.'</a:t>
-            </a:r>
-          </a:p>
-          <a:p>
-            <a:pPr>
-              <a:spcAft>
-                <a:spcPts val="600"/>
-              </a:spcAft>
-              <a:defRPr sz="1150">
-                <a:solidFill>
-                  <a:srgbClr val="FFFFFF"/>
-                </a:solidFill>
-                <a:latin typeface="Calibri"/>
-              </a:defRPr>
-            </a:pPr>
-            <a:r>
-              <a:t>• 100-Seat Urgency Triggers: Security clearance deadline countdowns driving C-Suite leaders to submit applications before the quota closes.</a:t>
-            </a:r>
-          </a:p>
-        </p:txBody>
-      </p:sp>
-      <p:sp>
-        <p:nvSpPr>
-          <p:cNvPr id="7" name="Rounded Rectangle 6"/>
+              <a:t>Luxury multi-page commemorative brochure formatted in high-resolution CMYK with gold-foil finish specs. Available as a downloadable print PDF and placed inside the physical delegate welcome briefcase.</a:t>
+            </a:r>
+          </a:p>
+        </p:txBody>
+      </p:sp>
+      <p:sp>
+        <p:nvSpPr>
+          <p:cNvPr id="8" name="Rounded Rectangle 7"/>
           <p:cNvSpPr/>
           <p:nvPr/>
         </p:nvSpPr>
         <p:spPr>
           <a:xfrm>
-            <a:off x="7589520" y="1645920"/>
-            <a:ext cx="3870655" cy="1371600"/>
+            <a:off x="6254496" y="1645920"/>
+            <a:ext cx="5193792" cy="2011680"/>
           </a:xfrm>
           <a:prstGeom prst="roundRect">
             <a:avLst/>
           </a:prstGeom>
           <a:solidFill>
-            <a:srgbClr val="122648"/>
+            <a:srgbClr val="0C1C36"/>
           </a:solidFill>
           <a:ln w="12700">
             <a:solidFill>
@@ -5575,16 +6141,40 @@
           </a:p>
         </p:txBody>
       </p:sp>
-      <p:sp>
-        <p:nvSpPr>
-          <p:cNvPr id="8" name="TextBox 7"/>
+      <p:pic>
+        <p:nvPicPr>
+          <p:cNvPr id="9" name="Picture 8" descr="icon_cert.png"/>
+          <p:cNvPicPr>
+            <a:picLocks noChangeAspect="1"/>
+          </p:cNvPicPr>
+          <p:nvPr/>
+        </p:nvPicPr>
+        <p:blipFill>
+          <a:blip r:embed="rId3"/>
+          <a:stretch>
+            <a:fillRect/>
+          </a:stretch>
+        </p:blipFill>
+        <p:spPr>
+          <a:xfrm>
+            <a:off x="6483096" y="1874520"/>
+            <a:ext cx="594360" cy="594360"/>
+          </a:xfrm>
+          <a:prstGeom prst="rect">
+            <a:avLst/>
+          </a:prstGeom>
+        </p:spPr>
+      </p:pic>
+      <p:sp>
+        <p:nvSpPr>
+          <p:cNvPr id="10" name="TextBox 9"/>
           <p:cNvSpPr txBox="1"/>
           <p:nvPr/>
         </p:nvSpPr>
         <p:spPr>
           <a:xfrm>
-            <a:off x="7772400" y="1828800"/>
-            <a:ext cx="3474720" cy="1005840"/>
+            <a:off x="7214616" y="1828800"/>
+            <a:ext cx="4023360" cy="1645920"/>
           </a:xfrm>
           <a:prstGeom prst="rect">
             <a:avLst/>
@@ -5598,48 +6188,51 @@
           <a:lstStyle/>
           <a:p>
             <a:pPr>
-              <a:defRPr sz="1400" b="1">
-                <a:solidFill>
-                  <a:srgbClr val="D4AF37"/>
+              <a:spcAft>
+                <a:spcPts val="600"/>
+              </a:spcAft>
+              <a:defRPr sz="1500" b="1">
+                <a:solidFill>
+                  <a:srgbClr val="FFFFFF"/>
                 </a:solidFill>
                 <a:latin typeface="Georgia"/>
               </a:defRPr>
             </a:pPr>
             <a:r>
-              <a:t>TARGET AUDIENCE</a:t>
-            </a:r>
-          </a:p>
-          <a:p>
-            <a:pPr>
-              <a:defRPr sz="1100">
-                <a:solidFill>
-                  <a:srgbClr val="FFFFFF"/>
+              <a:t>✦ Award Winner Press Release Kits</a:t>
+            </a:r>
+          </a:p>
+          <a:p>
+            <a:pPr>
+              <a:defRPr sz="1150">
+                <a:solidFill>
+                  <a:srgbClr val="B4C3D7"/>
                 </a:solidFill>
                 <a:latin typeface="Calibri"/>
               </a:defRPr>
             </a:pPr>
             <a:r>
-              <a:t>Indian Founders, CEOs, Investors (UK, India, UAE, US, Europe)</a:t>
-            </a:r>
-          </a:p>
-        </p:txBody>
-      </p:sp>
-      <p:sp>
-        <p:nvSpPr>
-          <p:cNvPr id="9" name="Rounded Rectangle 8"/>
+              <a:t>Pre-formatted press release templates and high-res digital award crests distributed to winners to instantly syndicate to international news agencies (Bloomberg, PTI, Financial Times, Reuters).</a:t>
+            </a:r>
+          </a:p>
+        </p:txBody>
+      </p:sp>
+      <p:sp>
+        <p:nvSpPr>
+          <p:cNvPr id="11" name="Rounded Rectangle 10"/>
           <p:cNvSpPr/>
           <p:nvPr/>
         </p:nvSpPr>
         <p:spPr>
           <a:xfrm>
-            <a:off x="7589520" y="3182112"/>
-            <a:ext cx="3870655" cy="1371600"/>
+            <a:off x="731520" y="3931920"/>
+            <a:ext cx="5193792" cy="2011680"/>
           </a:xfrm>
           <a:prstGeom prst="roundRect">
             <a:avLst/>
           </a:prstGeom>
           <a:solidFill>
-            <a:srgbClr val="122648"/>
+            <a:srgbClr val="0C1C36"/>
           </a:solidFill>
           <a:ln w="12700">
             <a:solidFill>
@@ -5669,16 +6262,40 @@
           </a:p>
         </p:txBody>
       </p:sp>
-      <p:sp>
-        <p:nvSpPr>
-          <p:cNvPr id="10" name="TextBox 9"/>
+      <p:pic>
+        <p:nvPicPr>
+          <p:cNvPr id="12" name="Picture 11" descr="shield_security.png"/>
+          <p:cNvPicPr>
+            <a:picLocks noChangeAspect="1"/>
+          </p:cNvPicPr>
+          <p:nvPr/>
+        </p:nvPicPr>
+        <p:blipFill>
+          <a:blip r:embed="rId4"/>
+          <a:stretch>
+            <a:fillRect/>
+          </a:stretch>
+        </p:blipFill>
+        <p:spPr>
+          <a:xfrm>
+            <a:off x="960120" y="4160520"/>
+            <a:ext cx="594360" cy="594360"/>
+          </a:xfrm>
+          <a:prstGeom prst="rect">
+            <a:avLst/>
+          </a:prstGeom>
+        </p:spPr>
+      </p:pic>
+      <p:sp>
+        <p:nvSpPr>
+          <p:cNvPr id="13" name="TextBox 12"/>
           <p:cNvSpPr txBox="1"/>
           <p:nvPr/>
         </p:nvSpPr>
         <p:spPr>
           <a:xfrm>
-            <a:off x="7772400" y="3364992"/>
-            <a:ext cx="3474720" cy="1005840"/>
+            <a:off x="1691640" y="4114800"/>
+            <a:ext cx="4023360" cy="1645920"/>
           </a:xfrm>
           <a:prstGeom prst="rect">
             <a:avLst/>
@@ -5692,48 +6309,51 @@
           <a:lstStyle/>
           <a:p>
             <a:pPr>
-              <a:defRPr sz="1400" b="1">
-                <a:solidFill>
-                  <a:srgbClr val="D4AF37"/>
+              <a:spcAft>
+                <a:spcPts val="600"/>
+              </a:spcAft>
+              <a:defRPr sz="1500" b="1">
+                <a:solidFill>
+                  <a:srgbClr val="F3E5AB"/>
                 </a:solidFill>
                 <a:latin typeface="Georgia"/>
               </a:defRPr>
             </a:pPr>
             <a:r>
-              <a:t>HASHTAG STRATEGY</a:t>
-            </a:r>
-          </a:p>
-          <a:p>
-            <a:pPr>
-              <a:defRPr sz="1100">
-                <a:solidFill>
-                  <a:srgbClr val="FFFFFF"/>
+              <a:t>✦ Bilateral MoU &amp; Deal Templates</a:t>
+            </a:r>
+          </a:p>
+          <a:p>
+            <a:pPr>
+              <a:defRPr sz="1150">
+                <a:solidFill>
+                  <a:srgbClr val="B4C3D7"/>
                 </a:solidFill>
                 <a:latin typeface="Calibri"/>
               </a:defRPr>
             </a:pPr>
             <a:r>
-              <a:t>#GlobalIndianAwards #HouseOfCommons #UKIndiaTrade #IBN2026</a:t>
-            </a:r>
-          </a:p>
-        </p:txBody>
-      </p:sp>
-      <p:sp>
-        <p:nvSpPr>
-          <p:cNvPr id="11" name="Rounded Rectangle 10"/>
+              <a:t>Standardized bilateral business cooperation and investment intent (MoU) templates provided during the Oxford &amp; Imperial forums to facilitate immediate partnership signings.</a:t>
+            </a:r>
+          </a:p>
+        </p:txBody>
+      </p:sp>
+      <p:sp>
+        <p:nvSpPr>
+          <p:cNvPr id="14" name="Rounded Rectangle 13"/>
           <p:cNvSpPr/>
           <p:nvPr/>
         </p:nvSpPr>
         <p:spPr>
           <a:xfrm>
-            <a:off x="7589520" y="4718304"/>
-            <a:ext cx="3870655" cy="1371600"/>
+            <a:off x="6254496" y="3931920"/>
+            <a:ext cx="5193792" cy="2011680"/>
           </a:xfrm>
           <a:prstGeom prst="roundRect">
             <a:avLst/>
           </a:prstGeom>
           <a:solidFill>
-            <a:srgbClr val="122648"/>
+            <a:srgbClr val="0C1C36"/>
           </a:solidFill>
           <a:ln w="12700">
             <a:solidFill>
@@ -5763,16 +6383,40 @@
           </a:p>
         </p:txBody>
       </p:sp>
-      <p:sp>
-        <p:nvSpPr>
-          <p:cNvPr id="12" name="TextBox 11"/>
+      <p:pic>
+        <p:nvPicPr>
+          <p:cNvPr id="15" name="Picture 14" descr="icon_badge.png"/>
+          <p:cNvPicPr>
+            <a:picLocks noChangeAspect="1"/>
+          </p:cNvPicPr>
+          <p:nvPr/>
+        </p:nvPicPr>
+        <p:blipFill>
+          <a:blip r:embed="rId5"/>
+          <a:stretch>
+            <a:fillRect/>
+          </a:stretch>
+        </p:blipFill>
+        <p:spPr>
+          <a:xfrm>
+            <a:off x="6483096" y="4160520"/>
+            <a:ext cx="594360" cy="594360"/>
+          </a:xfrm>
+          <a:prstGeom prst="rect">
+            <a:avLst/>
+          </a:prstGeom>
+        </p:spPr>
+      </p:pic>
+      <p:sp>
+        <p:nvSpPr>
+          <p:cNvPr id="16" name="TextBox 15"/>
           <p:cNvSpPr txBox="1"/>
           <p:nvPr/>
         </p:nvSpPr>
         <p:spPr>
           <a:xfrm>
-            <a:off x="7772400" y="4901184"/>
-            <a:ext cx="3474720" cy="1005840"/>
+            <a:off x="7214616" y="4114800"/>
+            <a:ext cx="4023360" cy="1645920"/>
           </a:xfrm>
           <a:prstGeom prst="rect">
             <a:avLst/>
@@ -5786,28 +6430,31 @@
           <a:lstStyle/>
           <a:p>
             <a:pPr>
-              <a:defRPr sz="1400" b="1">
-                <a:solidFill>
-                  <a:srgbClr val="D4AF37"/>
+              <a:spcAft>
+                <a:spcPts val="600"/>
+              </a:spcAft>
+              <a:defRPr sz="1500" b="1">
+                <a:solidFill>
+                  <a:srgbClr val="FFFFFF"/>
                 </a:solidFill>
                 <a:latin typeface="Georgia"/>
               </a:defRPr>
             </a:pPr>
             <a:r>
-              <a:t>CONVERSION HOOK</a:t>
-            </a:r>
-          </a:p>
-          <a:p>
-            <a:pPr>
-              <a:defRPr sz="1100">
-                <a:solidFill>
-                  <a:srgbClr val="FFFFFF"/>
+              <a:t>✦ Onsite Delegate Stationery &amp; Badges</a:t>
+            </a:r>
+          </a:p>
+          <a:p>
+            <a:pPr>
+              <a:defRPr sz="1150">
+                <a:solidFill>
+                  <a:srgbClr val="B4C3D7"/>
                 </a:solidFill>
                 <a:latin typeface="Calibri"/>
               </a:defRPr>
             </a:pPr>
             <a:r>
-              <a:t>Direct link to Tally Vetting Form with VIP nomination incentive</a:t>
+              <a:t>Custom embossed executive lanyards, personalized summit itinerary handbooks, table seating cards, and formal embossed Participation Certificates presented on Day 5.</a:t>
             </a:r>
           </a:p>
         </p:txBody>
@@ -5907,7 +6554,7 @@
               </a:defRPr>
             </a:pPr>
             <a:r>
-              <a:t>MARKETING STRATEGY: FACEBOOK</a:t>
+              <a:t>MARKETING STRATEGY: LINKEDIN</a:t>
             </a:r>
           </a:p>
           <a:p>
@@ -5920,7 +6567,7 @@
               </a:defRPr>
             </a:pPr>
             <a:r>
-              <a:t>Facebook Promotion: Diaspora Communities &amp; Multi-Card Carousels</a:t>
+              <a:t>LinkedIn Promotion: C-Suite Authority &amp; Thought Leadership</a:t>
             </a:r>
           </a:p>
         </p:txBody>
@@ -5977,104 +6624,7 @@
         <p:spPr>
           <a:xfrm>
             <a:off x="731520" y="1645920"/>
-            <a:ext cx="5193792" cy="2011680"/>
-          </a:xfrm>
-          <a:prstGeom prst="roundRect">
-            <a:avLst/>
-          </a:prstGeom>
-          <a:solidFill>
-            <a:srgbClr val="0C1C36"/>
-          </a:solidFill>
-          <a:ln w="12700">
-            <a:solidFill>
-              <a:srgbClr val="1E3A5F"/>
-            </a:solidFill>
-          </a:ln>
-        </p:spPr>
-        <p:style>
-          <a:lnRef idx="1">
-            <a:schemeClr val="accent1"/>
-          </a:lnRef>
-          <a:fillRef idx="3">
-            <a:schemeClr val="accent1"/>
-          </a:fillRef>
-          <a:effectRef idx="2">
-            <a:schemeClr val="accent1"/>
-          </a:effectRef>
-          <a:fontRef idx="minor">
-            <a:schemeClr val="lt1"/>
-          </a:fontRef>
-        </p:style>
-        <p:txBody>
-          <a:bodyPr rtlCol="0" anchor="ctr"/>
-          <a:lstStyle/>
-          <a:p>
-            <a:pPr algn="ctr"/>
-          </a:p>
-        </p:txBody>
-      </p:sp>
-      <p:sp>
-        <p:nvSpPr>
-          <p:cNvPr id="6" name="TextBox 5"/>
-          <p:cNvSpPr txBox="1"/>
-          <p:nvPr/>
-        </p:nvSpPr>
-        <p:spPr>
-          <a:xfrm>
-            <a:off x="1005840" y="1874520"/>
-            <a:ext cx="4645152" cy="1554480"/>
-          </a:xfrm>
-          <a:prstGeom prst="rect">
-            <a:avLst/>
-          </a:prstGeom>
-          <a:noFill/>
-        </p:spPr>
-        <p:txBody>
-          <a:bodyPr wrap="square">
-            <a:spAutoFit/>
-          </a:bodyPr>
-          <a:lstStyle/>
-          <a:p>
-            <a:pPr>
-              <a:spcAft>
-                <a:spcPts val="600"/>
-              </a:spcAft>
-              <a:defRPr sz="1500" b="1">
-                <a:solidFill>
-                  <a:srgbClr val="D4AF37"/>
-                </a:solidFill>
-                <a:latin typeface="Georgia"/>
-              </a:defRPr>
-            </a:pPr>
-            <a:r>
-              <a:t>✦ Official Event Page Hub</a:t>
-            </a:r>
-          </a:p>
-          <a:p>
-            <a:pPr>
-              <a:defRPr sz="1150">
-                <a:solidFill>
-                  <a:srgbClr val="B4C3D7"/>
-                </a:solidFill>
-                <a:latin typeface="Calibri"/>
-              </a:defRPr>
-            </a:pPr>
-            <a:r>
-              <a:t>Create a verified Facebook Event Page: 'Global Indian Business Excellence Awards 2026 — London', serving as the primary RSVP and live announcement center.</a:t>
-            </a:r>
-          </a:p>
-        </p:txBody>
-      </p:sp>
-      <p:sp>
-        <p:nvSpPr>
-          <p:cNvPr id="7" name="Rounded Rectangle 6"/>
-          <p:cNvSpPr/>
-          <p:nvPr/>
-        </p:nvSpPr>
-        <p:spPr>
-          <a:xfrm>
-            <a:off x="6254496" y="1645920"/>
-            <a:ext cx="5193792" cy="2011680"/>
+            <a:ext cx="6583680" cy="4480560"/>
           </a:xfrm>
           <a:prstGeom prst="roundRect">
             <a:avLst/>
@@ -6112,14 +6662,14 @@
       </p:sp>
       <p:sp>
         <p:nvSpPr>
-          <p:cNvPr id="8" name="TextBox 7"/>
+          <p:cNvPr id="6" name="TextBox 5"/>
           <p:cNvSpPr txBox="1"/>
           <p:nvPr/>
         </p:nvSpPr>
         <p:spPr>
           <a:xfrm>
-            <a:off x="6528816" y="1874520"/>
-            <a:ext cx="4645152" cy="1554480"/>
+            <a:off x="1005840" y="1874519"/>
+            <a:ext cx="6035040" cy="4023360"/>
           </a:xfrm>
           <a:prstGeom prst="rect">
             <a:avLst/>
@@ -6134,50 +6684,117 @@
           <a:p>
             <a:pPr>
               <a:spcAft>
+                <a:spcPts val="1000"/>
+              </a:spcAft>
+              <a:defRPr sz="1400" b="1">
+                <a:solidFill>
+                  <a:srgbClr val="D4AF37"/>
+                </a:solidFill>
+                <a:latin typeface="Georgia"/>
+              </a:defRPr>
+            </a:pPr>
+            <a:r>
+              <a:t>CORE MARKETING ENGINE: B2B &amp; EXECUTIVE VISIBILITY</a:t>
+            </a:r>
+          </a:p>
+          <a:p>
+            <a:pPr>
+              <a:spcAft>
                 <a:spcPts val="600"/>
               </a:spcAft>
-              <a:defRPr sz="1500" b="1">
+              <a:defRPr sz="1150">
                 <a:solidFill>
                   <a:srgbClr val="FFFFFF"/>
                 </a:solidFill>
-                <a:latin typeface="Georgia"/>
-              </a:defRPr>
-            </a:pPr>
-            <a:r>
-              <a:t>✦ Multi-Slide Carousel Ads</a:t>
-            </a:r>
-          </a:p>
-          <a:p>
-            <a:pPr>
+                <a:latin typeface="Calibri"/>
+              </a:defRPr>
+            </a:pPr>
+            <a:r>
+              <a:t>• Institutional Announcement: Positioning the summit as an exclusive UK–India bilateral leadership summit held inside the British Parliament.</a:t>
+            </a:r>
+          </a:p>
+          <a:p>
+            <a:pPr>
+              <a:spcAft>
+                <a:spcPts val="600"/>
+              </a:spcAft>
               <a:defRPr sz="1150">
                 <a:solidFill>
-                  <a:srgbClr val="B4C3D7"/>
+                  <a:srgbClr val="FFFFFF"/>
                 </a:solidFill>
                 <a:latin typeface="Calibri"/>
               </a:defRPr>
             </a:pPr>
             <a:r>
-              <a:t>'5 Days. 3 Historic Institutions. 100 Leaders.' Multi-card ads showcasing Big Ben, the House of Commons, Gala ballroom, Oxford, and Cambridge.</a:t>
-            </a:r>
-          </a:p>
-        </p:txBody>
-      </p:sp>
-      <p:sp>
-        <p:nvSpPr>
-          <p:cNvPr id="9" name="Rounded Rectangle 8"/>
+              <a:t>• Founder &amp; President Voice: Personal executive notes from Velou Singaram and board members inviting peers to join the private corridor.</a:t>
+            </a:r>
+          </a:p>
+          <a:p>
+            <a:pPr>
+              <a:spcAft>
+                <a:spcPts val="600"/>
+              </a:spcAft>
+              <a:defRPr sz="1150">
+                <a:solidFill>
+                  <a:srgbClr val="FFFFFF"/>
+                </a:solidFill>
+                <a:latin typeface="Calibri"/>
+              </a:defRPr>
+            </a:pPr>
+            <a:r>
+              <a:t>• Academic Immersion Highlights: Spotlighting Oxford, Cambridge, and Imperial College London as catalysts for deep-tech and enterprise scaling.</a:t>
+            </a:r>
+          </a:p>
+          <a:p>
+            <a:pPr>
+              <a:spcAft>
+                <a:spcPts val="600"/>
+              </a:spcAft>
+              <a:defRPr sz="1150">
+                <a:solidFill>
+                  <a:srgbClr val="FFFFFF"/>
+                </a:solidFill>
+                <a:latin typeface="Calibri"/>
+              </a:defRPr>
+            </a:pPr>
+            <a:r>
+              <a:t>• Delegate &amp; Speaker Spotlights: Elegant digital badge creatives announcing vetted attendees: 'Proud to announce [Name] as an Executive Delegate.'</a:t>
+            </a:r>
+          </a:p>
+          <a:p>
+            <a:pPr>
+              <a:spcAft>
+                <a:spcPts val="600"/>
+              </a:spcAft>
+              <a:defRPr sz="1150">
+                <a:solidFill>
+                  <a:srgbClr val="FFFFFF"/>
+                </a:solidFill>
+                <a:latin typeface="Calibri"/>
+              </a:defRPr>
+            </a:pPr>
+            <a:r>
+              <a:t>• 100-Seat Urgency Triggers: Security clearance deadline countdowns driving C-Suite leaders to submit applications before the quota closes.</a:t>
+            </a:r>
+          </a:p>
+        </p:txBody>
+      </p:sp>
+      <p:sp>
+        <p:nvSpPr>
+          <p:cNvPr id="7" name="Rounded Rectangle 6"/>
           <p:cNvSpPr/>
           <p:nvPr/>
         </p:nvSpPr>
         <p:spPr>
           <a:xfrm>
-            <a:off x="731520" y="3931920"/>
-            <a:ext cx="5193792" cy="2011680"/>
+            <a:off x="7589520" y="1645920"/>
+            <a:ext cx="3870655" cy="1371600"/>
           </a:xfrm>
           <a:prstGeom prst="roundRect">
             <a:avLst/>
           </a:prstGeom>
           <a:solidFill>
-            <a:srgbClr val="0C1C36"/>
+            <a:srgbClr val="122648"/>
           </a:solidFill>
           <a:ln w="12700">
             <a:solidFill>
@@ -6209,14 +6826,14 @@
       </p:sp>
       <p:sp>
         <p:nvSpPr>
-          <p:cNvPr id="10" name="TextBox 9"/>
+          <p:cNvPr id="8" name="TextBox 7"/>
           <p:cNvSpPr txBox="1"/>
           <p:nvPr/>
         </p:nvSpPr>
         <p:spPr>
           <a:xfrm>
-            <a:off x="1005840" y="4160520"/>
-            <a:ext cx="4645152" cy="1554480"/>
+            <a:off x="7772400" y="1828800"/>
+            <a:ext cx="3474720" cy="1005840"/>
           </a:xfrm>
           <a:prstGeom prst="rect">
             <a:avLst/>
@@ -6230,51 +6847,48 @@
           <a:lstStyle/>
           <a:p>
             <a:pPr>
-              <a:spcAft>
-                <a:spcPts val="600"/>
-              </a:spcAft>
-              <a:defRPr sz="1500" b="1">
-                <a:solidFill>
-                  <a:srgbClr val="F3E5AB"/>
+              <a:defRPr sz="1400" b="1">
+                <a:solidFill>
+                  <a:srgbClr val="D4AF37"/>
                 </a:solidFill>
                 <a:latin typeface="Georgia"/>
               </a:defRPr>
             </a:pPr>
             <a:r>
-              <a:t>✦ Business Diaspora Groups</a:t>
-            </a:r>
-          </a:p>
-          <a:p>
-            <a:pPr>
-              <a:defRPr sz="1150">
-                <a:solidFill>
-                  <a:srgbClr val="B4C3D7"/>
+              <a:t>TARGET AUDIENCE</a:t>
+            </a:r>
+          </a:p>
+          <a:p>
+            <a:pPr>
+              <a:defRPr sz="1100">
+                <a:solidFill>
+                  <a:srgbClr val="FFFFFF"/>
                 </a:solidFill>
                 <a:latin typeface="Calibri"/>
               </a:defRPr>
             </a:pPr>
             <a:r>
-              <a:t>Engage established British-Indian diaspora groups, executive alumni networks (IIT/IIM UK Chapters), and bilateral business councils.</a:t>
-            </a:r>
-          </a:p>
-        </p:txBody>
-      </p:sp>
-      <p:sp>
-        <p:nvSpPr>
-          <p:cNvPr id="11" name="Rounded Rectangle 10"/>
+              <a:t>Indian Founders, CEOs, Investors (UK, India, UAE, US, Europe)</a:t>
+            </a:r>
+          </a:p>
+        </p:txBody>
+      </p:sp>
+      <p:sp>
+        <p:nvSpPr>
+          <p:cNvPr id="9" name="Rounded Rectangle 8"/>
           <p:cNvSpPr/>
           <p:nvPr/>
         </p:nvSpPr>
         <p:spPr>
           <a:xfrm>
-            <a:off x="6254496" y="3931920"/>
-            <a:ext cx="5193792" cy="2011680"/>
+            <a:off x="7589520" y="3182112"/>
+            <a:ext cx="3870655" cy="1371600"/>
           </a:xfrm>
           <a:prstGeom prst="roundRect">
             <a:avLst/>
           </a:prstGeom>
           <a:solidFill>
-            <a:srgbClr val="0C1C36"/>
+            <a:srgbClr val="122648"/>
           </a:solidFill>
           <a:ln w="12700">
             <a:solidFill>
@@ -6306,14 +6920,14 @@
       </p:sp>
       <p:sp>
         <p:nvSpPr>
-          <p:cNvPr id="12" name="TextBox 11"/>
+          <p:cNvPr id="10" name="TextBox 9"/>
           <p:cNvSpPr txBox="1"/>
           <p:nvPr/>
         </p:nvSpPr>
         <p:spPr>
           <a:xfrm>
-            <a:off x="6528816" y="4160520"/>
-            <a:ext cx="4645152" cy="1554480"/>
+            <a:off x="7772400" y="3364992"/>
+            <a:ext cx="3474720" cy="1005840"/>
           </a:xfrm>
           <a:prstGeom prst="rect">
             <a:avLst/>
@@ -6327,31 +6941,122 @@
           <a:lstStyle/>
           <a:p>
             <a:pPr>
-              <a:spcAft>
-                <a:spcPts val="600"/>
-              </a:spcAft>
-              <a:defRPr sz="1500" b="1">
+              <a:defRPr sz="1400" b="1">
+                <a:solidFill>
+                  <a:srgbClr val="D4AF37"/>
+                </a:solidFill>
+                <a:latin typeface="Georgia"/>
+              </a:defRPr>
+            </a:pPr>
+            <a:r>
+              <a:t>HASHTAG STRATEGY</a:t>
+            </a:r>
+          </a:p>
+          <a:p>
+            <a:pPr>
+              <a:defRPr sz="1100">
                 <a:solidFill>
                   <a:srgbClr val="FFFFFF"/>
                 </a:solidFill>
+                <a:latin typeface="Calibri"/>
+              </a:defRPr>
+            </a:pPr>
+            <a:r>
+              <a:t>#GlobalIndianAwards #HouseOfCommons #UKIndiaTrade #IBN2026</a:t>
+            </a:r>
+          </a:p>
+        </p:txBody>
+      </p:sp>
+      <p:sp>
+        <p:nvSpPr>
+          <p:cNvPr id="11" name="Rounded Rectangle 10"/>
+          <p:cNvSpPr/>
+          <p:nvPr/>
+        </p:nvSpPr>
+        <p:spPr>
+          <a:xfrm>
+            <a:off x="7589520" y="4718304"/>
+            <a:ext cx="3870655" cy="1371600"/>
+          </a:xfrm>
+          <a:prstGeom prst="roundRect">
+            <a:avLst/>
+          </a:prstGeom>
+          <a:solidFill>
+            <a:srgbClr val="122648"/>
+          </a:solidFill>
+          <a:ln w="12700">
+            <a:solidFill>
+              <a:srgbClr val="1E3A5F"/>
+            </a:solidFill>
+          </a:ln>
+        </p:spPr>
+        <p:style>
+          <a:lnRef idx="1">
+            <a:schemeClr val="accent1"/>
+          </a:lnRef>
+          <a:fillRef idx="3">
+            <a:schemeClr val="accent1"/>
+          </a:fillRef>
+          <a:effectRef idx="2">
+            <a:schemeClr val="accent1"/>
+          </a:effectRef>
+          <a:fontRef idx="minor">
+            <a:schemeClr val="lt1"/>
+          </a:fontRef>
+        </p:style>
+        <p:txBody>
+          <a:bodyPr rtlCol="0" anchor="ctr"/>
+          <a:lstStyle/>
+          <a:p>
+            <a:pPr algn="ctr"/>
+          </a:p>
+        </p:txBody>
+      </p:sp>
+      <p:sp>
+        <p:nvSpPr>
+          <p:cNvPr id="12" name="TextBox 11"/>
+          <p:cNvSpPr txBox="1"/>
+          <p:nvPr/>
+        </p:nvSpPr>
+        <p:spPr>
+          <a:xfrm>
+            <a:off x="7772400" y="4901184"/>
+            <a:ext cx="3474720" cy="1005840"/>
+          </a:xfrm>
+          <a:prstGeom prst="rect">
+            <a:avLst/>
+          </a:prstGeom>
+          <a:noFill/>
+        </p:spPr>
+        <p:txBody>
+          <a:bodyPr wrap="square">
+            <a:spAutoFit/>
+          </a:bodyPr>
+          <a:lstStyle/>
+          <a:p>
+            <a:pPr>
+              <a:defRPr sz="1400" b="1">
+                <a:solidFill>
+                  <a:srgbClr val="D4AF37"/>
+                </a:solidFill>
                 <a:latin typeface="Georgia"/>
               </a:defRPr>
             </a:pPr>
             <a:r>
-              <a:t>✦ Video Teaser Campaigns</a:t>
-            </a:r>
-          </a:p>
-          <a:p>
-            <a:pPr>
-              <a:defRPr sz="1150">
-                <a:solidFill>
-                  <a:srgbClr val="B4C3D7"/>
+              <a:t>CONVERSION HOOK</a:t>
+            </a:r>
+          </a:p>
+          <a:p>
+            <a:pPr>
+              <a:defRPr sz="1100">
+                <a:solidFill>
+                  <a:srgbClr val="FFFFFF"/>
                 </a:solidFill>
                 <a:latin typeface="Calibri"/>
               </a:defRPr>
             </a:pPr>
             <a:r>
-              <a:t>Short 30-second cinematic teasers highlighting the prestige of Westminster and academic innovation hubs, targeted to mature business demographics.</a:t>
+              <a:t>Direct link to Tally Vetting Form with VIP nomination incentive</a:t>
             </a:r>
           </a:p>
         </p:txBody>
@@ -6451,7 +7156,7 @@
               </a:defRPr>
             </a:pPr>
             <a:r>
-              <a:t>MARKETING STRATEGY: INSTAGRAM</a:t>
+              <a:t>MARKETING STRATEGY: FACEBOOK</a:t>
             </a:r>
           </a:p>
           <a:p>
@@ -6464,7 +7169,7 @@
               </a:defRPr>
             </a:pPr>
             <a:r>
-              <a:t>Instagram Promotion: Visual Prestige, Cinematic Reels &amp; Stories</a:t>
+              <a:t>Facebook Promotion: Diaspora Communities &amp; Multi-Card Carousels</a:t>
             </a:r>
           </a:p>
         </p:txBody>
@@ -6521,6 +7226,103 @@
         <p:spPr>
           <a:xfrm>
             <a:off x="731520" y="1645920"/>
+            <a:ext cx="5193792" cy="2011680"/>
+          </a:xfrm>
+          <a:prstGeom prst="roundRect">
+            <a:avLst/>
+          </a:prstGeom>
+          <a:solidFill>
+            <a:srgbClr val="0C1C36"/>
+          </a:solidFill>
+          <a:ln w="12700">
+            <a:solidFill>
+              <a:srgbClr val="1E3A5F"/>
+            </a:solidFill>
+          </a:ln>
+        </p:spPr>
+        <p:style>
+          <a:lnRef idx="1">
+            <a:schemeClr val="accent1"/>
+          </a:lnRef>
+          <a:fillRef idx="3">
+            <a:schemeClr val="accent1"/>
+          </a:fillRef>
+          <a:effectRef idx="2">
+            <a:schemeClr val="accent1"/>
+          </a:effectRef>
+          <a:fontRef idx="minor">
+            <a:schemeClr val="lt1"/>
+          </a:fontRef>
+        </p:style>
+        <p:txBody>
+          <a:bodyPr rtlCol="0" anchor="ctr"/>
+          <a:lstStyle/>
+          <a:p>
+            <a:pPr algn="ctr"/>
+          </a:p>
+        </p:txBody>
+      </p:sp>
+      <p:sp>
+        <p:nvSpPr>
+          <p:cNvPr id="6" name="TextBox 5"/>
+          <p:cNvSpPr txBox="1"/>
+          <p:nvPr/>
+        </p:nvSpPr>
+        <p:spPr>
+          <a:xfrm>
+            <a:off x="1005840" y="1874520"/>
+            <a:ext cx="4645152" cy="1554480"/>
+          </a:xfrm>
+          <a:prstGeom prst="rect">
+            <a:avLst/>
+          </a:prstGeom>
+          <a:noFill/>
+        </p:spPr>
+        <p:txBody>
+          <a:bodyPr wrap="square">
+            <a:spAutoFit/>
+          </a:bodyPr>
+          <a:lstStyle/>
+          <a:p>
+            <a:pPr>
+              <a:spcAft>
+                <a:spcPts val="600"/>
+              </a:spcAft>
+              <a:defRPr sz="1500" b="1">
+                <a:solidFill>
+                  <a:srgbClr val="D4AF37"/>
+                </a:solidFill>
+                <a:latin typeface="Georgia"/>
+              </a:defRPr>
+            </a:pPr>
+            <a:r>
+              <a:t>✦ Official Event Page Hub</a:t>
+            </a:r>
+          </a:p>
+          <a:p>
+            <a:pPr>
+              <a:defRPr sz="1150">
+                <a:solidFill>
+                  <a:srgbClr val="B4C3D7"/>
+                </a:solidFill>
+                <a:latin typeface="Calibri"/>
+              </a:defRPr>
+            </a:pPr>
+            <a:r>
+              <a:t>Create a verified Facebook Event Page: 'Global Indian Business Excellence Awards 2026 — London', serving as the primary RSVP and live announcement center.</a:t>
+            </a:r>
+          </a:p>
+        </p:txBody>
+      </p:sp>
+      <p:sp>
+        <p:nvSpPr>
+          <p:cNvPr id="7" name="Rounded Rectangle 6"/>
+          <p:cNvSpPr/>
+          <p:nvPr/>
+        </p:nvSpPr>
+        <p:spPr>
+          <a:xfrm>
+            <a:off x="6254496" y="1645920"/>
             <a:ext cx="5193792" cy="2011680"/>
           </a:xfrm>
           <a:prstGeom prst="roundRect">
@@ -6559,13 +7361,13 @@
       </p:sp>
       <p:sp>
         <p:nvSpPr>
-          <p:cNvPr id="6" name="TextBox 5"/>
+          <p:cNvPr id="8" name="TextBox 7"/>
           <p:cNvSpPr txBox="1"/>
           <p:nvPr/>
         </p:nvSpPr>
         <p:spPr>
           <a:xfrm>
-            <a:off x="1005840" y="1874520"/>
+            <a:off x="6528816" y="1874520"/>
             <a:ext cx="4645152" cy="1554480"/>
           </a:xfrm>
           <a:prstGeom prst="rect">
@@ -6585,13 +7387,13 @@
               </a:spcAft>
               <a:defRPr sz="1500" b="1">
                 <a:solidFill>
-                  <a:srgbClr val="D4AF37"/>
+                  <a:srgbClr val="FFFFFF"/>
                 </a:solidFill>
                 <a:latin typeface="Georgia"/>
               </a:defRPr>
             </a:pPr>
             <a:r>
-              <a:t>✦ Cinematic Luxury Reels (9:16)</a:t>
+              <a:t>✦ Multi-Slide Carousel Ads</a:t>
             </a:r>
           </a:p>
           <a:p>
@@ -6604,20 +7406,20 @@
               </a:defRPr>
             </a:pPr>
             <a:r>
-              <a:t>35-second high-energy cinematic clips: Big Ben twilight aerials, red-carpet Black Tie gala, Oxford colleges, and the Parliament terrace.</a:t>
-            </a:r>
-          </a:p>
-        </p:txBody>
-      </p:sp>
-      <p:sp>
-        <p:nvSpPr>
-          <p:cNvPr id="7" name="Rounded Rectangle 6"/>
+              <a:t>'5 Days. 3 Historic Institutions. 100 Leaders.' Multi-card ads showcasing Big Ben, the House of Commons, Gala ballroom, Oxford, and Cambridge.</a:t>
+            </a:r>
+          </a:p>
+        </p:txBody>
+      </p:sp>
+      <p:sp>
+        <p:nvSpPr>
+          <p:cNvPr id="9" name="Rounded Rectangle 8"/>
           <p:cNvSpPr/>
           <p:nvPr/>
         </p:nvSpPr>
         <p:spPr>
           <a:xfrm>
-            <a:off x="6254496" y="1645920"/>
+            <a:off x="731520" y="3931920"/>
             <a:ext cx="5193792" cy="2011680"/>
           </a:xfrm>
           <a:prstGeom prst="roundRect">
@@ -6656,13 +7458,13 @@
       </p:sp>
       <p:sp>
         <p:nvSpPr>
-          <p:cNvPr id="8" name="TextBox 7"/>
+          <p:cNvPr id="10" name="TextBox 9"/>
           <p:cNvSpPr txBox="1"/>
           <p:nvPr/>
         </p:nvSpPr>
         <p:spPr>
           <a:xfrm>
-            <a:off x="6528816" y="1874520"/>
+            <a:off x="1005840" y="4160520"/>
             <a:ext cx="4645152" cy="1554480"/>
           </a:xfrm>
           <a:prstGeom prst="rect">
@@ -6682,13 +7484,13 @@
               </a:spcAft>
               <a:defRPr sz="1500" b="1">
                 <a:solidFill>
-                  <a:srgbClr val="FFFFFF"/>
+                  <a:srgbClr val="F3E5AB"/>
                 </a:solidFill>
                 <a:latin typeface="Georgia"/>
               </a:defRPr>
             </a:pPr>
             <a:r>
-              <a:t>✦ High-Engagement Feed Carousels</a:t>
+              <a:t>✦ Business Diaspora Groups</a:t>
             </a:r>
           </a:p>
           <a:p>
@@ -6701,20 +7503,20 @@
               </a:defRPr>
             </a:pPr>
             <a:r>
-              <a:t>10-slide luxury slide carousels breaking down each day's itinerary, delegate package inclusions, and award categories with dark navy/gold aesthetics.</a:t>
-            </a:r>
-          </a:p>
-        </p:txBody>
-      </p:sp>
-      <p:sp>
-        <p:nvSpPr>
-          <p:cNvPr id="9" name="Rounded Rectangle 8"/>
+              <a:t>Engage established British-Indian diaspora groups, executive alumni networks (IIT/IIM UK Chapters), and bilateral business councils.</a:t>
+            </a:r>
+          </a:p>
+        </p:txBody>
+      </p:sp>
+      <p:sp>
+        <p:nvSpPr>
+          <p:cNvPr id="11" name="Rounded Rectangle 10"/>
           <p:cNvSpPr/>
           <p:nvPr/>
         </p:nvSpPr>
         <p:spPr>
           <a:xfrm>
-            <a:off x="731520" y="3931920"/>
+            <a:off x="6254496" y="3931920"/>
             <a:ext cx="5193792" cy="2011680"/>
           </a:xfrm>
           <a:prstGeom prst="roundRect">
@@ -6753,13 +7555,13 @@
       </p:sp>
       <p:sp>
         <p:nvSpPr>
-          <p:cNvPr id="10" name="TextBox 9"/>
+          <p:cNvPr id="12" name="TextBox 11"/>
           <p:cNvSpPr txBox="1"/>
           <p:nvPr/>
         </p:nvSpPr>
         <p:spPr>
           <a:xfrm>
-            <a:off x="1005840" y="4160520"/>
+            <a:off x="6528816" y="4160520"/>
             <a:ext cx="4645152" cy="1554480"/>
           </a:xfrm>
           <a:prstGeom prst="rect">
@@ -6779,13 +7581,13 @@
               </a:spcAft>
               <a:defRPr sz="1500" b="1">
                 <a:solidFill>
-                  <a:srgbClr val="F3E5AB"/>
+                  <a:srgbClr val="FFFFFF"/>
                 </a:solidFill>
                 <a:latin typeface="Georgia"/>
               </a:defRPr>
             </a:pPr>
             <a:r>
-              <a:t>✦ Interactive Countdown Stories</a:t>
+              <a:t>✦ Video Teaser Campaigns</a:t>
             </a:r>
           </a:p>
           <a:p>
@@ -6798,104 +7600,7 @@
               </a:defRPr>
             </a:pPr>
             <a:r>
-              <a:t>Countdown stickers for registration closing, 'Meet the Committee' story cards, dress-code style inspiration (Black Tie / Tuxedo), and live Q&amp;A stickers.</a:t>
-            </a:r>
-          </a:p>
-        </p:txBody>
-      </p:sp>
-      <p:sp>
-        <p:nvSpPr>
-          <p:cNvPr id="11" name="Rounded Rectangle 10"/>
-          <p:cNvSpPr/>
-          <p:nvPr/>
-        </p:nvSpPr>
-        <p:spPr>
-          <a:xfrm>
-            <a:off x="6254496" y="3931920"/>
-            <a:ext cx="5193792" cy="2011680"/>
-          </a:xfrm>
-          <a:prstGeom prst="roundRect">
-            <a:avLst/>
-          </a:prstGeom>
-          <a:solidFill>
-            <a:srgbClr val="0C1C36"/>
-          </a:solidFill>
-          <a:ln w="12700">
-            <a:solidFill>
-              <a:srgbClr val="1E3A5F"/>
-            </a:solidFill>
-          </a:ln>
-        </p:spPr>
-        <p:style>
-          <a:lnRef idx="1">
-            <a:schemeClr val="accent1"/>
-          </a:lnRef>
-          <a:fillRef idx="3">
-            <a:schemeClr val="accent1"/>
-          </a:fillRef>
-          <a:effectRef idx="2">
-            <a:schemeClr val="accent1"/>
-          </a:effectRef>
-          <a:fontRef idx="minor">
-            <a:schemeClr val="lt1"/>
-          </a:fontRef>
-        </p:style>
-        <p:txBody>
-          <a:bodyPr rtlCol="0" anchor="ctr"/>
-          <a:lstStyle/>
-          <a:p>
-            <a:pPr algn="ctr"/>
-          </a:p>
-        </p:txBody>
-      </p:sp>
-      <p:sp>
-        <p:nvSpPr>
-          <p:cNvPr id="12" name="TextBox 11"/>
-          <p:cNvSpPr txBox="1"/>
-          <p:nvPr/>
-        </p:nvSpPr>
-        <p:spPr>
-          <a:xfrm>
-            <a:off x="6528816" y="4160520"/>
-            <a:ext cx="4645152" cy="1554480"/>
-          </a:xfrm>
-          <a:prstGeom prst="rect">
-            <a:avLst/>
-          </a:prstGeom>
-          <a:noFill/>
-        </p:spPr>
-        <p:txBody>
-          <a:bodyPr wrap="square">
-            <a:spAutoFit/>
-          </a:bodyPr>
-          <a:lstStyle/>
-          <a:p>
-            <a:pPr>
-              <a:spcAft>
-                <a:spcPts val="600"/>
-              </a:spcAft>
-              <a:defRPr sz="1500" b="1">
-                <a:solidFill>
-                  <a:srgbClr val="FFFFFF"/>
-                </a:solidFill>
-                <a:latin typeface="Georgia"/>
-              </a:defRPr>
-            </a:pPr>
-            <a:r>
-              <a:t>✦ Curated Highlight Covers</a:t>
-            </a:r>
-          </a:p>
-          <a:p>
-            <a:pPr>
-              <a:defRPr sz="1150">
-                <a:solidFill>
-                  <a:srgbClr val="B4C3D7"/>
-                </a:solidFill>
-                <a:latin typeface="Calibri"/>
-              </a:defRPr>
-            </a:pPr>
-            <a:r>
-              <a:t>Permanent profile highlights on Instagram: 🏛️ Parliament | 🗓️ Itinerary | 🎓 Oxford &amp; Cambridge | 👔 Dress Code | 🎟️ Apply.</a:t>
+              <a:t>Short 30-second cinematic teasers highlighting the prestige of Westminster and academic innovation hubs, targeted to mature business demographics.</a:t>
             </a:r>
           </a:p>
         </p:txBody>
@@ -6995,7 +7700,7 @@
               </a:defRPr>
             </a:pPr>
             <a:r>
-              <a:t>MARKETING STRATEGY: WHATSAPP</a:t>
+              <a:t>MARKETING STRATEGY: INSTAGRAM</a:t>
             </a:r>
           </a:p>
           <a:p>
@@ -7008,7 +7713,7 @@
               </a:defRPr>
             </a:pPr>
             <a:r>
-              <a:t>WhatsApp Strategy: High-Touch VIP Concierge &amp; Direct Outreach</a:t>
+              <a:t>Instagram Promotion: Visual Prestige, Cinematic Reels &amp; Stories</a:t>
             </a:r>
           </a:p>
         </p:txBody>
@@ -7065,6 +7770,103 @@
         <p:spPr>
           <a:xfrm>
             <a:off x="731520" y="1645920"/>
+            <a:ext cx="5193792" cy="2011680"/>
+          </a:xfrm>
+          <a:prstGeom prst="roundRect">
+            <a:avLst/>
+          </a:prstGeom>
+          <a:solidFill>
+            <a:srgbClr val="0C1C36"/>
+          </a:solidFill>
+          <a:ln w="19050">
+            <a:solidFill>
+              <a:srgbClr val="D4AF37"/>
+            </a:solidFill>
+          </a:ln>
+        </p:spPr>
+        <p:style>
+          <a:lnRef idx="1">
+            <a:schemeClr val="accent1"/>
+          </a:lnRef>
+          <a:fillRef idx="3">
+            <a:schemeClr val="accent1"/>
+          </a:fillRef>
+          <a:effectRef idx="2">
+            <a:schemeClr val="accent1"/>
+          </a:effectRef>
+          <a:fontRef idx="minor">
+            <a:schemeClr val="lt1"/>
+          </a:fontRef>
+        </p:style>
+        <p:txBody>
+          <a:bodyPr rtlCol="0" anchor="ctr"/>
+          <a:lstStyle/>
+          <a:p>
+            <a:pPr algn="ctr"/>
+          </a:p>
+        </p:txBody>
+      </p:sp>
+      <p:sp>
+        <p:nvSpPr>
+          <p:cNvPr id="6" name="TextBox 5"/>
+          <p:cNvSpPr txBox="1"/>
+          <p:nvPr/>
+        </p:nvSpPr>
+        <p:spPr>
+          <a:xfrm>
+            <a:off x="1005840" y="1874520"/>
+            <a:ext cx="4645152" cy="1554480"/>
+          </a:xfrm>
+          <a:prstGeom prst="rect">
+            <a:avLst/>
+          </a:prstGeom>
+          <a:noFill/>
+        </p:spPr>
+        <p:txBody>
+          <a:bodyPr wrap="square">
+            <a:spAutoFit/>
+          </a:bodyPr>
+          <a:lstStyle/>
+          <a:p>
+            <a:pPr>
+              <a:spcAft>
+                <a:spcPts val="600"/>
+              </a:spcAft>
+              <a:defRPr sz="1500" b="1">
+                <a:solidFill>
+                  <a:srgbClr val="D4AF37"/>
+                </a:solidFill>
+                <a:latin typeface="Georgia"/>
+              </a:defRPr>
+            </a:pPr>
+            <a:r>
+              <a:t>✦ Cinematic Luxury Reels (9:16)</a:t>
+            </a:r>
+          </a:p>
+          <a:p>
+            <a:pPr>
+              <a:defRPr sz="1150">
+                <a:solidFill>
+                  <a:srgbClr val="B4C3D7"/>
+                </a:solidFill>
+                <a:latin typeface="Calibri"/>
+              </a:defRPr>
+            </a:pPr>
+            <a:r>
+              <a:t>35-second high-energy cinematic clips: Big Ben twilight aerials, red-carpet Black Tie gala, Oxford colleges, and the Parliament terrace.</a:t>
+            </a:r>
+          </a:p>
+        </p:txBody>
+      </p:sp>
+      <p:sp>
+        <p:nvSpPr>
+          <p:cNvPr id="7" name="Rounded Rectangle 6"/>
+          <p:cNvSpPr/>
+          <p:nvPr/>
+        </p:nvSpPr>
+        <p:spPr>
+          <a:xfrm>
+            <a:off x="6254496" y="1645920"/>
             <a:ext cx="5193792" cy="2011680"/>
           </a:xfrm>
           <a:prstGeom prst="roundRect">
@@ -7103,13 +7905,13 @@
       </p:sp>
       <p:sp>
         <p:nvSpPr>
-          <p:cNvPr id="6" name="TextBox 5"/>
+          <p:cNvPr id="8" name="TextBox 7"/>
           <p:cNvSpPr txBox="1"/>
           <p:nvPr/>
         </p:nvSpPr>
         <p:spPr>
           <a:xfrm>
-            <a:off x="1005840" y="1874520"/>
+            <a:off x="6528816" y="1874520"/>
             <a:ext cx="4645152" cy="1554480"/>
           </a:xfrm>
           <a:prstGeom prst="rect">
@@ -7129,13 +7931,13 @@
               </a:spcAft>
               <a:defRPr sz="1500" b="1">
                 <a:solidFill>
-                  <a:srgbClr val="D4AF37"/>
+                  <a:srgbClr val="FFFFFF"/>
                 </a:solidFill>
                 <a:latin typeface="Georgia"/>
               </a:defRPr>
             </a:pPr>
             <a:r>
-              <a:t>✦ Personalized 1-on-1 VIP Outreach</a:t>
+              <a:t>✦ High-Engagement Feed Carousels</a:t>
             </a:r>
           </a:p>
           <a:p>
@@ -7148,104 +7950,7 @@
               </a:defRPr>
             </a:pPr>
             <a:r>
-              <a:t>Direct confidential invitations sent to nominated CEOs and industry titans with personalized PDF invitations and brochure attachments.</a:t>
-            </a:r>
-          </a:p>
-        </p:txBody>
-      </p:sp>
-      <p:sp>
-        <p:nvSpPr>
-          <p:cNvPr id="7" name="Rounded Rectangle 6"/>
-          <p:cNvSpPr/>
-          <p:nvPr/>
-        </p:nvSpPr>
-        <p:spPr>
-          <a:xfrm>
-            <a:off x="6254496" y="1645920"/>
-            <a:ext cx="5193792" cy="2011680"/>
-          </a:xfrm>
-          <a:prstGeom prst="roundRect">
-            <a:avLst/>
-          </a:prstGeom>
-          <a:solidFill>
-            <a:srgbClr val="0C1C36"/>
-          </a:solidFill>
-          <a:ln w="19050">
-            <a:solidFill>
-              <a:srgbClr val="D4AF37"/>
-            </a:solidFill>
-          </a:ln>
-        </p:spPr>
-        <p:style>
-          <a:lnRef idx="1">
-            <a:schemeClr val="accent1"/>
-          </a:lnRef>
-          <a:fillRef idx="3">
-            <a:schemeClr val="accent1"/>
-          </a:fillRef>
-          <a:effectRef idx="2">
-            <a:schemeClr val="accent1"/>
-          </a:effectRef>
-          <a:fontRef idx="minor">
-            <a:schemeClr val="lt1"/>
-          </a:fontRef>
-        </p:style>
-        <p:txBody>
-          <a:bodyPr rtlCol="0" anchor="ctr"/>
-          <a:lstStyle/>
-          <a:p>
-            <a:pPr algn="ctr"/>
-          </a:p>
-        </p:txBody>
-      </p:sp>
-      <p:sp>
-        <p:nvSpPr>
-          <p:cNvPr id="8" name="TextBox 7"/>
-          <p:cNvSpPr txBox="1"/>
-          <p:nvPr/>
-        </p:nvSpPr>
-        <p:spPr>
-          <a:xfrm>
-            <a:off x="6528816" y="1874520"/>
-            <a:ext cx="4645152" cy="1554480"/>
-          </a:xfrm>
-          <a:prstGeom prst="rect">
-            <a:avLst/>
-          </a:prstGeom>
-          <a:noFill/>
-        </p:spPr>
-        <p:txBody>
-          <a:bodyPr wrap="square">
-            <a:spAutoFit/>
-          </a:bodyPr>
-          <a:lstStyle/>
-          <a:p>
-            <a:pPr>
-              <a:spcAft>
-                <a:spcPts val="600"/>
-              </a:spcAft>
-              <a:defRPr sz="1500" b="1">
-                <a:solidFill>
-                  <a:srgbClr val="FFFFFF"/>
-                </a:solidFill>
-                <a:latin typeface="Georgia"/>
-              </a:defRPr>
-            </a:pPr>
-            <a:r>
-              <a:t>✦ Instant Secretariat Hotline</a:t>
-            </a:r>
-          </a:p>
-          <a:p>
-            <a:pPr>
-              <a:defRPr sz="1150">
-                <a:solidFill>
-                  <a:srgbClr val="B4C3D7"/>
-                </a:solidFill>
-                <a:latin typeface="Calibri"/>
-              </a:defRPr>
-            </a:pPr>
-            <a:r>
-              <a:t>One-tap direct chat with Event Coordinator Subha Austalekshmi (+44 7587 260254) for immediate answers regarding itinerary, hotels, and visas.</a:t>
+              <a:t>10-slide luxury slide carousels breaking down each day's itinerary, delegate package inclusions, and award categories with dark navy/gold aesthetics.</a:t>
             </a:r>
           </a:p>
         </p:txBody>
@@ -7329,7 +8034,7 @@
               </a:defRPr>
             </a:pPr>
             <a:r>
-              <a:t>✦ Accredited Delegate Broadcast Channel</a:t>
+              <a:t>✦ Interactive Countdown Stories</a:t>
             </a:r>
           </a:p>
           <a:p>
@@ -7342,7 +8047,7 @@
               </a:defRPr>
             </a:pPr>
             <a:r>
-              <a:t>Private, announcement-only broadcast group for the 100 confirmed delegates providing daily security timing and coach departure updates.</a:t>
+              <a:t>Countdown stickers for registration closing, 'Meet the Committee' story cards, dress-code style inspiration (Black Tie / Tuxedo), and live Q&amp;A stickers.</a:t>
             </a:r>
           </a:p>
         </p:txBody>
@@ -7426,7 +8131,7 @@
               </a:defRPr>
             </a:pPr>
             <a:r>
-              <a:t>✦ Interactive WhatsApp Chatbot Flow</a:t>
+              <a:t>✦ Curated Highlight Covers</a:t>
             </a:r>
           </a:p>
           <a:p>
@@ -7439,7 +8144,7 @@
               </a:defRPr>
             </a:pPr>
             <a:r>
-              <a:t>Automated FAQ assistant answering queries on dress code, Cromwell Green passport requirements, and coach pickup points in central London.</a:t>
+              <a:t>Permanent profile highlights on Instagram: 🏛️ Parliament | 🗓️ Itinerary | 🎓 Oxford &amp; Cambridge | 👔 Dress Code | 🎟️ Apply.</a:t>
             </a:r>
           </a:p>
         </p:txBody>
@@ -7539,7 +8244,7 @@
               </a:defRPr>
             </a:pPr>
             <a:r>
-              <a:t>MARKETING STRATEGY: EMAIL</a:t>
+              <a:t>MARKETING STRATEGY: WHATSAPP</a:t>
             </a:r>
           </a:p>
           <a:p>
@@ -7552,7 +8257,7 @@
               </a:defRPr>
             </a:pPr>
             <a:r>
-              <a:t>Email Newsletter Campaign: 4-Stage High-Conversion VIP Drip</a:t>
+              <a:t>WhatsApp Strategy: High-Touch VIP Concierge &amp; Direct Outreach</a:t>
             </a:r>
           </a:p>
         </p:txBody>
@@ -7609,7 +8314,104 @@
         <p:spPr>
           <a:xfrm>
             <a:off x="731520" y="1645920"/>
-            <a:ext cx="2587752" cy="4480560"/>
+            <a:ext cx="5193792" cy="2011680"/>
+          </a:xfrm>
+          <a:prstGeom prst="roundRect">
+            <a:avLst/>
+          </a:prstGeom>
+          <a:solidFill>
+            <a:srgbClr val="0C1C36"/>
+          </a:solidFill>
+          <a:ln w="12700">
+            <a:solidFill>
+              <a:srgbClr val="1E3A5F"/>
+            </a:solidFill>
+          </a:ln>
+        </p:spPr>
+        <p:style>
+          <a:lnRef idx="1">
+            <a:schemeClr val="accent1"/>
+          </a:lnRef>
+          <a:fillRef idx="3">
+            <a:schemeClr val="accent1"/>
+          </a:fillRef>
+          <a:effectRef idx="2">
+            <a:schemeClr val="accent1"/>
+          </a:effectRef>
+          <a:fontRef idx="minor">
+            <a:schemeClr val="lt1"/>
+          </a:fontRef>
+        </p:style>
+        <p:txBody>
+          <a:bodyPr rtlCol="0" anchor="ctr"/>
+          <a:lstStyle/>
+          <a:p>
+            <a:pPr algn="ctr"/>
+          </a:p>
+        </p:txBody>
+      </p:sp>
+      <p:sp>
+        <p:nvSpPr>
+          <p:cNvPr id="6" name="TextBox 5"/>
+          <p:cNvSpPr txBox="1"/>
+          <p:nvPr/>
+        </p:nvSpPr>
+        <p:spPr>
+          <a:xfrm>
+            <a:off x="1005840" y="1874520"/>
+            <a:ext cx="4645152" cy="1554480"/>
+          </a:xfrm>
+          <a:prstGeom prst="rect">
+            <a:avLst/>
+          </a:prstGeom>
+          <a:noFill/>
+        </p:spPr>
+        <p:txBody>
+          <a:bodyPr wrap="square">
+            <a:spAutoFit/>
+          </a:bodyPr>
+          <a:lstStyle/>
+          <a:p>
+            <a:pPr>
+              <a:spcAft>
+                <a:spcPts val="600"/>
+              </a:spcAft>
+              <a:defRPr sz="1500" b="1">
+                <a:solidFill>
+                  <a:srgbClr val="D4AF37"/>
+                </a:solidFill>
+                <a:latin typeface="Georgia"/>
+              </a:defRPr>
+            </a:pPr>
+            <a:r>
+              <a:t>✦ Personalized 1-on-1 VIP Outreach</a:t>
+            </a:r>
+          </a:p>
+          <a:p>
+            <a:pPr>
+              <a:defRPr sz="1150">
+                <a:solidFill>
+                  <a:srgbClr val="B4C3D7"/>
+                </a:solidFill>
+                <a:latin typeface="Calibri"/>
+              </a:defRPr>
+            </a:pPr>
+            <a:r>
+              <a:t>Direct confidential invitations sent to nominated CEOs and industry titans with personalized PDF invitations and brochure attachments.</a:t>
+            </a:r>
+          </a:p>
+        </p:txBody>
+      </p:sp>
+      <p:sp>
+        <p:nvSpPr>
+          <p:cNvPr id="7" name="Rounded Rectangle 6"/>
+          <p:cNvSpPr/>
+          <p:nvPr/>
+        </p:nvSpPr>
+        <p:spPr>
+          <a:xfrm>
+            <a:off x="6254496" y="1645920"/>
+            <a:ext cx="5193792" cy="2011680"/>
           </a:xfrm>
           <a:prstGeom prst="roundRect">
             <a:avLst/>
@@ -7647,14 +8449,14 @@
       </p:sp>
       <p:sp>
         <p:nvSpPr>
-          <p:cNvPr id="6" name="TextBox 5"/>
+          <p:cNvPr id="8" name="TextBox 7"/>
           <p:cNvSpPr txBox="1"/>
           <p:nvPr/>
         </p:nvSpPr>
         <p:spPr>
           <a:xfrm>
-            <a:off x="914400" y="1920240"/>
-            <a:ext cx="2221992" cy="3931920"/>
+            <a:off x="6528816" y="1874520"/>
+            <a:ext cx="4645152" cy="1554480"/>
           </a:xfrm>
           <a:prstGeom prst="rect">
             <a:avLst/>
@@ -7669,60 +8471,44 @@
           <a:p>
             <a:pPr>
               <a:spcAft>
-                <a:spcPts val="400"/>
-              </a:spcAft>
-              <a:defRPr sz="1200" b="1">
-                <a:solidFill>
-                  <a:srgbClr val="D4AF37"/>
-                </a:solidFill>
-                <a:latin typeface="Georgia"/>
-              </a:defRPr>
-            </a:pPr>
-            <a:r>
-              <a:t>EMAIL 1: VIP INVITATION</a:t>
-            </a:r>
-          </a:p>
-          <a:p>
-            <a:pPr>
-              <a:spcAft>
-                <a:spcPts val="1200"/>
+                <a:spcPts val="600"/>
               </a:spcAft>
               <a:defRPr sz="1500" b="1">
                 <a:solidFill>
                   <a:srgbClr val="FFFFFF"/>
                 </a:solidFill>
+                <a:latin typeface="Georgia"/>
+              </a:defRPr>
+            </a:pPr>
+            <a:r>
+              <a:t>✦ Instant Secretariat Hotline</a:t>
+            </a:r>
+          </a:p>
+          <a:p>
+            <a:pPr>
+              <a:defRPr sz="1150">
+                <a:solidFill>
+                  <a:srgbClr val="B4C3D7"/>
+                </a:solidFill>
                 <a:latin typeface="Calibri"/>
               </a:defRPr>
             </a:pPr>
             <a:r>
-              <a:t>The British Parliament Calling</a:t>
-            </a:r>
-          </a:p>
-          <a:p>
-            <a:pPr>
-              <a:defRPr sz="1150">
-                <a:solidFill>
-                  <a:srgbClr val="B4C3D7"/>
-                </a:solidFill>
-                <a:latin typeface="Calibri"/>
-              </a:defRPr>
-            </a:pPr>
-            <a:r>
-              <a:t>Formal high-touch invitation addressed directly to C-Suite leaders detailing the 5-day summit, House of Commons prestige, and the 100-seat ceiling.</a:t>
-            </a:r>
-          </a:p>
-        </p:txBody>
-      </p:sp>
-      <p:sp>
-        <p:nvSpPr>
-          <p:cNvPr id="7" name="Rounded Rectangle 6"/>
+              <a:t>One-tap direct chat with Event Coordinator Subha Austalekshmi (+44 7587 260254) for immediate answers regarding itinerary, hotels, and visas.</a:t>
+            </a:r>
+          </a:p>
+        </p:txBody>
+      </p:sp>
+      <p:sp>
+        <p:nvSpPr>
+          <p:cNvPr id="9" name="Rounded Rectangle 8"/>
           <p:cNvSpPr/>
           <p:nvPr/>
         </p:nvSpPr>
         <p:spPr>
           <a:xfrm>
-            <a:off x="3502152" y="1645920"/>
-            <a:ext cx="2587752" cy="4480560"/>
+            <a:off x="731520" y="3931920"/>
+            <a:ext cx="5193792" cy="2011680"/>
           </a:xfrm>
           <a:prstGeom prst="roundRect">
             <a:avLst/>
@@ -7760,14 +8546,14 @@
       </p:sp>
       <p:sp>
         <p:nvSpPr>
-          <p:cNvPr id="8" name="TextBox 7"/>
+          <p:cNvPr id="10" name="TextBox 9"/>
           <p:cNvSpPr txBox="1"/>
           <p:nvPr/>
         </p:nvSpPr>
         <p:spPr>
           <a:xfrm>
-            <a:off x="3685032" y="1920240"/>
-            <a:ext cx="2221992" cy="3931920"/>
+            <a:off x="1005840" y="4160520"/>
+            <a:ext cx="4645152" cy="1554480"/>
           </a:xfrm>
           <a:prstGeom prst="rect">
             <a:avLst/>
@@ -7782,60 +8568,44 @@
           <a:p>
             <a:pPr>
               <a:spcAft>
-                <a:spcPts val="400"/>
-              </a:spcAft>
-              <a:defRPr sz="1200" b="1">
-                <a:solidFill>
-                  <a:srgbClr val="FFFFFF"/>
-                </a:solidFill>
-                <a:latin typeface="Georgia"/>
-              </a:defRPr>
-            </a:pPr>
-            <a:r>
-              <a:t>EMAIL 2: ACADEMIC FOCUS</a:t>
-            </a:r>
-          </a:p>
-          <a:p>
-            <a:pPr>
-              <a:spcAft>
-                <a:spcPts val="1200"/>
+                <a:spcPts val="600"/>
               </a:spcAft>
               <a:defRPr sz="1500" b="1">
                 <a:solidFill>
-                  <a:srgbClr val="FFFFFF"/>
+                  <a:srgbClr val="F3E5AB"/>
+                </a:solidFill>
+                <a:latin typeface="Georgia"/>
+              </a:defRPr>
+            </a:pPr>
+            <a:r>
+              <a:t>✦ Accredited Delegate Broadcast Channel</a:t>
+            </a:r>
+          </a:p>
+          <a:p>
+            <a:pPr>
+              <a:defRPr sz="1150">
+                <a:solidFill>
+                  <a:srgbClr val="B4C3D7"/>
                 </a:solidFill>
                 <a:latin typeface="Calibri"/>
               </a:defRPr>
             </a:pPr>
             <a:r>
-              <a:t>Beyond Westminster: Oxford &amp; Cambridge</a:t>
-            </a:r>
-          </a:p>
-          <a:p>
-            <a:pPr>
-              <a:defRPr sz="1150">
-                <a:solidFill>
-                  <a:srgbClr val="B4C3D7"/>
-                </a:solidFill>
-                <a:latin typeface="Calibri"/>
-              </a:defRPr>
-            </a:pPr>
-            <a:r>
-              <a:t>Deep dive into the Oxford Business Leadership Forum, Cambridge deep-tech cluster, and Imperial College London research commercialisation.</a:t>
-            </a:r>
-          </a:p>
-        </p:txBody>
-      </p:sp>
-      <p:sp>
-        <p:nvSpPr>
-          <p:cNvPr id="9" name="Rounded Rectangle 8"/>
+              <a:t>Private, announcement-only broadcast group for the 100 confirmed delegates providing daily security timing and coach departure updates.</a:t>
+            </a:r>
+          </a:p>
+        </p:txBody>
+      </p:sp>
+      <p:sp>
+        <p:nvSpPr>
+          <p:cNvPr id="11" name="Rounded Rectangle 10"/>
           <p:cNvSpPr/>
           <p:nvPr/>
         </p:nvSpPr>
         <p:spPr>
           <a:xfrm>
-            <a:off x="6272783" y="1645920"/>
-            <a:ext cx="2587752" cy="4480560"/>
+            <a:off x="6254496" y="3931920"/>
+            <a:ext cx="5193792" cy="2011680"/>
           </a:xfrm>
           <a:prstGeom prst="roundRect">
             <a:avLst/>
@@ -7873,14 +8643,14 @@
       </p:sp>
       <p:sp>
         <p:nvSpPr>
-          <p:cNvPr id="10" name="TextBox 9"/>
+          <p:cNvPr id="12" name="TextBox 11"/>
           <p:cNvSpPr txBox="1"/>
           <p:nvPr/>
         </p:nvSpPr>
         <p:spPr>
           <a:xfrm>
-            <a:off x="6455663" y="1920240"/>
-            <a:ext cx="2221992" cy="3931920"/>
+            <a:off x="6528816" y="4160520"/>
+            <a:ext cx="4645152" cy="1554480"/>
           </a:xfrm>
           <a:prstGeom prst="rect">
             <a:avLst/>
@@ -7895,159 +8665,30 @@
           <a:p>
             <a:pPr>
               <a:spcAft>
-                <a:spcPts val="400"/>
-              </a:spcAft>
-              <a:defRPr sz="1200" b="1">
-                <a:solidFill>
-                  <a:srgbClr val="F3E5AB"/>
-                </a:solidFill>
-                <a:latin typeface="Georgia"/>
-              </a:defRPr>
-            </a:pPr>
-            <a:r>
-              <a:t>EMAIL 3: URGENCY &amp; CLEARANCE</a:t>
-            </a:r>
-          </a:p>
-          <a:p>
-            <a:pPr>
-              <a:spcAft>
-                <a:spcPts val="1200"/>
+                <a:spcPts val="600"/>
               </a:spcAft>
               <a:defRPr sz="1500" b="1">
                 <a:solidFill>
                   <a:srgbClr val="FFFFFF"/>
                 </a:solidFill>
+                <a:latin typeface="Georgia"/>
+              </a:defRPr>
+            </a:pPr>
+            <a:r>
+              <a:t>✦ Interactive WhatsApp Chatbot Flow</a:t>
+            </a:r>
+          </a:p>
+          <a:p>
+            <a:pPr>
+              <a:defRPr sz="1150">
+                <a:solidFill>
+                  <a:srgbClr val="B4C3D7"/>
+                </a:solidFill>
                 <a:latin typeface="Calibri"/>
               </a:defRPr>
             </a:pPr>
             <a:r>
-              <a:t>Capacity Warning &amp; Security Lead Times</a:t>
-            </a:r>
-          </a:p>
-          <a:p>
-            <a:pPr>
-              <a:defRPr sz="1150">
-                <a:solidFill>
-                  <a:srgbClr val="B4C3D7"/>
-                </a:solidFill>
-                <a:latin typeface="Calibri"/>
-              </a:defRPr>
-            </a:pPr>
-            <a:r>
-              <a:t>Alerting invited leaders that 80% of capacity is allocated and parliamentary accreditation requires passport details well in advance.</a:t>
-            </a:r>
-          </a:p>
-        </p:txBody>
-      </p:sp>
-      <p:sp>
-        <p:nvSpPr>
-          <p:cNvPr id="11" name="Rounded Rectangle 10"/>
-          <p:cNvSpPr/>
-          <p:nvPr/>
-        </p:nvSpPr>
-        <p:spPr>
-          <a:xfrm>
-            <a:off x="9043416" y="1645920"/>
-            <a:ext cx="2587752" cy="4480560"/>
-          </a:xfrm>
-          <a:prstGeom prst="roundRect">
-            <a:avLst/>
-          </a:prstGeom>
-          <a:solidFill>
-            <a:srgbClr val="0C1C36"/>
-          </a:solidFill>
-          <a:ln w="12700">
-            <a:solidFill>
-              <a:srgbClr val="1E3A5F"/>
-            </a:solidFill>
-          </a:ln>
-        </p:spPr>
-        <p:style>
-          <a:lnRef idx="1">
-            <a:schemeClr val="accent1"/>
-          </a:lnRef>
-          <a:fillRef idx="3">
-            <a:schemeClr val="accent1"/>
-          </a:fillRef>
-          <a:effectRef idx="2">
-            <a:schemeClr val="accent1"/>
-          </a:effectRef>
-          <a:fontRef idx="minor">
-            <a:schemeClr val="lt1"/>
-          </a:fontRef>
-        </p:style>
-        <p:txBody>
-          <a:bodyPr rtlCol="0" anchor="ctr"/>
-          <a:lstStyle/>
-          <a:p>
-            <a:pPr algn="ctr"/>
-          </a:p>
-        </p:txBody>
-      </p:sp>
-      <p:sp>
-        <p:nvSpPr>
-          <p:cNvPr id="12" name="TextBox 11"/>
-          <p:cNvSpPr txBox="1"/>
-          <p:nvPr/>
-        </p:nvSpPr>
-        <p:spPr>
-          <a:xfrm>
-            <a:off x="9226296" y="1920240"/>
-            <a:ext cx="2221992" cy="3931920"/>
-          </a:xfrm>
-          <a:prstGeom prst="rect">
-            <a:avLst/>
-          </a:prstGeom>
-          <a:noFill/>
-        </p:spPr>
-        <p:txBody>
-          <a:bodyPr wrap="square">
-            <a:spAutoFit/>
-          </a:bodyPr>
-          <a:lstStyle/>
-          <a:p>
-            <a:pPr>
-              <a:spcAft>
-                <a:spcPts val="400"/>
-              </a:spcAft>
-              <a:defRPr sz="1200" b="1">
-                <a:solidFill>
-                  <a:srgbClr val="FFFFFF"/>
-                </a:solidFill>
-                <a:latin typeface="Georgia"/>
-              </a:defRPr>
-            </a:pPr>
-            <a:r>
-              <a:t>EMAIL 4: ONBOARDING BRIEFING</a:t>
-            </a:r>
-          </a:p>
-          <a:p>
-            <a:pPr>
-              <a:spcAft>
-                <a:spcPts val="1200"/>
-              </a:spcAft>
-              <a:defRPr sz="1500" b="1">
-                <a:solidFill>
-                  <a:srgbClr val="FFFFFF"/>
-                </a:solidFill>
-                <a:latin typeface="Calibri"/>
-              </a:defRPr>
-            </a:pPr>
-            <a:r>
-              <a:t>Confirmed Delegate Welcome Package</a:t>
-            </a:r>
-          </a:p>
-          <a:p>
-            <a:pPr>
-              <a:defRPr sz="1150">
-                <a:solidFill>
-                  <a:srgbClr val="B4C3D7"/>
-                </a:solidFill>
-                <a:latin typeface="Calibri"/>
-              </a:defRPr>
-            </a:pPr>
-            <a:r>
-              <a:t>Dispatched to confirmed leaders with dress codes (Black Tie / Formal), security clearance confirmations, and mobile app download credentials.</a:t>
+              <a:t>Automated FAQ assistant answering queries on dress code, Cromwell Green passport requirements, and coach pickup points in central London.</a:t>
             </a:r>
           </a:p>
         </p:txBody>
@@ -8147,7 +8788,7 @@
               </a:defRPr>
             </a:pPr>
             <a:r>
-              <a:t>MARKETING EXECUTION</a:t>
+              <a:t>MARKETING STRATEGY: EMAIL</a:t>
             </a:r>
           </a:p>
           <a:p>
@@ -8160,7 +8801,7 @@
               </a:defRPr>
             </a:pPr>
             <a:r>
-              <a:t>Integrated Multi-Channel Conversion Funnel</a:t>
+              <a:t>Email Newsletter Campaign: 4-Stage High-Conversion VIP Drip</a:t>
             </a:r>
           </a:p>
         </p:txBody>
@@ -8217,6 +8858,119 @@
         <p:spPr>
           <a:xfrm>
             <a:off x="731520" y="1645920"/>
+            <a:ext cx="2587752" cy="4480560"/>
+          </a:xfrm>
+          <a:prstGeom prst="roundRect">
+            <a:avLst/>
+          </a:prstGeom>
+          <a:solidFill>
+            <a:srgbClr val="0C1C36"/>
+          </a:solidFill>
+          <a:ln w="19050">
+            <a:solidFill>
+              <a:srgbClr val="D4AF37"/>
+            </a:solidFill>
+          </a:ln>
+        </p:spPr>
+        <p:style>
+          <a:lnRef idx="1">
+            <a:schemeClr val="accent1"/>
+          </a:lnRef>
+          <a:fillRef idx="3">
+            <a:schemeClr val="accent1"/>
+          </a:fillRef>
+          <a:effectRef idx="2">
+            <a:schemeClr val="accent1"/>
+          </a:effectRef>
+          <a:fontRef idx="minor">
+            <a:schemeClr val="lt1"/>
+          </a:fontRef>
+        </p:style>
+        <p:txBody>
+          <a:bodyPr rtlCol="0" anchor="ctr"/>
+          <a:lstStyle/>
+          <a:p>
+            <a:pPr algn="ctr"/>
+          </a:p>
+        </p:txBody>
+      </p:sp>
+      <p:sp>
+        <p:nvSpPr>
+          <p:cNvPr id="6" name="TextBox 5"/>
+          <p:cNvSpPr txBox="1"/>
+          <p:nvPr/>
+        </p:nvSpPr>
+        <p:spPr>
+          <a:xfrm>
+            <a:off x="914400" y="1920240"/>
+            <a:ext cx="2221992" cy="3931920"/>
+          </a:xfrm>
+          <a:prstGeom prst="rect">
+            <a:avLst/>
+          </a:prstGeom>
+          <a:noFill/>
+        </p:spPr>
+        <p:txBody>
+          <a:bodyPr wrap="square">
+            <a:spAutoFit/>
+          </a:bodyPr>
+          <a:lstStyle/>
+          <a:p>
+            <a:pPr>
+              <a:spcAft>
+                <a:spcPts val="400"/>
+              </a:spcAft>
+              <a:defRPr sz="1200" b="1">
+                <a:solidFill>
+                  <a:srgbClr val="D4AF37"/>
+                </a:solidFill>
+                <a:latin typeface="Georgia"/>
+              </a:defRPr>
+            </a:pPr>
+            <a:r>
+              <a:t>EMAIL 1: VIP INVITATION</a:t>
+            </a:r>
+          </a:p>
+          <a:p>
+            <a:pPr>
+              <a:spcAft>
+                <a:spcPts val="1200"/>
+              </a:spcAft>
+              <a:defRPr sz="1500" b="1">
+                <a:solidFill>
+                  <a:srgbClr val="FFFFFF"/>
+                </a:solidFill>
+                <a:latin typeface="Calibri"/>
+              </a:defRPr>
+            </a:pPr>
+            <a:r>
+              <a:t>The British Parliament Calling</a:t>
+            </a:r>
+          </a:p>
+          <a:p>
+            <a:pPr>
+              <a:defRPr sz="1150">
+                <a:solidFill>
+                  <a:srgbClr val="B4C3D7"/>
+                </a:solidFill>
+                <a:latin typeface="Calibri"/>
+              </a:defRPr>
+            </a:pPr>
+            <a:r>
+              <a:t>Formal high-touch invitation addressed directly to C-Suite leaders detailing the 5-day summit, House of Commons prestige, and the 100-seat ceiling.</a:t>
+            </a:r>
+          </a:p>
+        </p:txBody>
+      </p:sp>
+      <p:sp>
+        <p:nvSpPr>
+          <p:cNvPr id="7" name="Rounded Rectangle 6"/>
+          <p:cNvSpPr/>
+          <p:nvPr/>
+        </p:nvSpPr>
+        <p:spPr>
+          <a:xfrm>
+            <a:off x="3502152" y="1645920"/>
             <a:ext cx="2587752" cy="4480560"/>
           </a:xfrm>
           <a:prstGeom prst="roundRect">
@@ -8255,13 +9009,13 @@
       </p:sp>
       <p:sp>
         <p:nvSpPr>
-          <p:cNvPr id="6" name="TextBox 5"/>
+          <p:cNvPr id="8" name="TextBox 7"/>
           <p:cNvSpPr txBox="1"/>
           <p:nvPr/>
         </p:nvSpPr>
         <p:spPr>
           <a:xfrm>
-            <a:off x="914400" y="1920240"/>
+            <a:off x="3685032" y="1920240"/>
             <a:ext cx="2221992" cy="3931920"/>
           </a:xfrm>
           <a:prstGeom prst="rect">
@@ -8281,13 +9035,13 @@
               </a:spcAft>
               <a:defRPr sz="1200" b="1">
                 <a:solidFill>
-                  <a:srgbClr val="D4AF37"/>
+                  <a:srgbClr val="FFFFFF"/>
                 </a:solidFill>
                 <a:latin typeface="Georgia"/>
               </a:defRPr>
             </a:pPr>
             <a:r>
-              <a:t>STAGE 1: AWARENESS</a:t>
+              <a:t>EMAIL 2: ACADEMIC FOCUS</a:t>
             </a:r>
           </a:p>
           <a:p>
@@ -8295,7 +9049,7 @@
               <a:spcAft>
                 <a:spcPts val="1200"/>
               </a:spcAft>
-              <a:defRPr sz="1600" b="1">
+              <a:defRPr sz="1500" b="1">
                 <a:solidFill>
                   <a:srgbClr val="FFFFFF"/>
                 </a:solidFill>
@@ -8303,12 +9057,12 @@
               </a:defRPr>
             </a:pPr>
             <a:r>
-              <a:t>LinkedIn &amp; Media PR</a:t>
-            </a:r>
-          </a:p>
-          <a:p>
-            <a:pPr>
-              <a:defRPr sz="1200">
+              <a:t>Beyond Westminster: Oxford &amp; Cambridge</a:t>
+            </a:r>
+          </a:p>
+          <a:p>
+            <a:pPr>
+              <a:defRPr sz="1150">
                 <a:solidFill>
                   <a:srgbClr val="B4C3D7"/>
                 </a:solidFill>
@@ -8316,20 +9070,20 @@
               </a:defRPr>
             </a:pPr>
             <a:r>
-              <a:t>Thought leadership articles, official press releases, and executive announcements establishing global prestige.</a:t>
-            </a:r>
-          </a:p>
-        </p:txBody>
-      </p:sp>
-      <p:sp>
-        <p:nvSpPr>
-          <p:cNvPr id="7" name="Rounded Rectangle 6"/>
+              <a:t>Deep dive into the Oxford Business Leadership Forum, Cambridge deep-tech cluster, and Imperial College London research commercialisation.</a:t>
+            </a:r>
+          </a:p>
+        </p:txBody>
+      </p:sp>
+      <p:sp>
+        <p:nvSpPr>
+          <p:cNvPr id="9" name="Rounded Rectangle 8"/>
           <p:cNvSpPr/>
           <p:nvPr/>
         </p:nvSpPr>
         <p:spPr>
           <a:xfrm>
-            <a:off x="3502152" y="1645920"/>
+            <a:off x="6272783" y="1645920"/>
             <a:ext cx="2587752" cy="4480560"/>
           </a:xfrm>
           <a:prstGeom prst="roundRect">
@@ -8368,13 +9122,13 @@
       </p:sp>
       <p:sp>
         <p:nvSpPr>
-          <p:cNvPr id="8" name="TextBox 7"/>
+          <p:cNvPr id="10" name="TextBox 9"/>
           <p:cNvSpPr txBox="1"/>
           <p:nvPr/>
         </p:nvSpPr>
         <p:spPr>
           <a:xfrm>
-            <a:off x="3685032" y="1920240"/>
+            <a:off x="6455663" y="1920240"/>
             <a:ext cx="2221992" cy="3931920"/>
           </a:xfrm>
           <a:prstGeom prst="rect">
@@ -8394,13 +9148,13 @@
               </a:spcAft>
               <a:defRPr sz="1200" b="1">
                 <a:solidFill>
-                  <a:srgbClr val="D4AF37"/>
+                  <a:srgbClr val="F3E5AB"/>
                 </a:solidFill>
                 <a:latin typeface="Georgia"/>
               </a:defRPr>
             </a:pPr>
             <a:r>
-              <a:t>STAGE 2: ENGAGEMENT</a:t>
+              <a:t>EMAIL 3: URGENCY &amp; CLEARANCE</a:t>
             </a:r>
           </a:p>
           <a:p>
@@ -8408,7 +9162,7 @@
               <a:spcAft>
                 <a:spcPts val="1200"/>
               </a:spcAft>
-              <a:defRPr sz="1600" b="1">
+              <a:defRPr sz="1500" b="1">
                 <a:solidFill>
                   <a:srgbClr val="FFFFFF"/>
                 </a:solidFill>
@@ -8416,12 +9170,12 @@
               </a:defRPr>
             </a:pPr>
             <a:r>
-              <a:t>Instagram &amp; Facebook</a:t>
-            </a:r>
-          </a:p>
-          <a:p>
-            <a:pPr>
-              <a:defRPr sz="1200">
+              <a:t>Capacity Warning &amp; Security Lead Times</a:t>
+            </a:r>
+          </a:p>
+          <a:p>
+            <a:pPr>
+              <a:defRPr sz="1150">
                 <a:solidFill>
                   <a:srgbClr val="B4C3D7"/>
                 </a:solidFill>
@@ -8429,120 +9183,7 @@
               </a:defRPr>
             </a:pPr>
             <a:r>
-              <a:t>Cinematic video reels, carousel ads, and community discussions highlighting Oxford, Cambridge, and the Gala.</a:t>
-            </a:r>
-          </a:p>
-        </p:txBody>
-      </p:sp>
-      <p:sp>
-        <p:nvSpPr>
-          <p:cNvPr id="9" name="Rounded Rectangle 8"/>
-          <p:cNvSpPr/>
-          <p:nvPr/>
-        </p:nvSpPr>
-        <p:spPr>
-          <a:xfrm>
-            <a:off x="6272783" y="1645920"/>
-            <a:ext cx="2587752" cy="4480560"/>
-          </a:xfrm>
-          <a:prstGeom prst="roundRect">
-            <a:avLst/>
-          </a:prstGeom>
-          <a:solidFill>
-            <a:srgbClr val="0C1C36"/>
-          </a:solidFill>
-          <a:ln w="19050">
-            <a:solidFill>
-              <a:srgbClr val="D4AF37"/>
-            </a:solidFill>
-          </a:ln>
-        </p:spPr>
-        <p:style>
-          <a:lnRef idx="1">
-            <a:schemeClr val="accent1"/>
-          </a:lnRef>
-          <a:fillRef idx="3">
-            <a:schemeClr val="accent1"/>
-          </a:fillRef>
-          <a:effectRef idx="2">
-            <a:schemeClr val="accent1"/>
-          </a:effectRef>
-          <a:fontRef idx="minor">
-            <a:schemeClr val="lt1"/>
-          </a:fontRef>
-        </p:style>
-        <p:txBody>
-          <a:bodyPr rtlCol="0" anchor="ctr"/>
-          <a:lstStyle/>
-          <a:p>
-            <a:pPr algn="ctr"/>
-          </a:p>
-        </p:txBody>
-      </p:sp>
-      <p:sp>
-        <p:nvSpPr>
-          <p:cNvPr id="10" name="TextBox 9"/>
-          <p:cNvSpPr txBox="1"/>
-          <p:nvPr/>
-        </p:nvSpPr>
-        <p:spPr>
-          <a:xfrm>
-            <a:off x="6455663" y="1920240"/>
-            <a:ext cx="2221992" cy="3931920"/>
-          </a:xfrm>
-          <a:prstGeom prst="rect">
-            <a:avLst/>
-          </a:prstGeom>
-          <a:noFill/>
-        </p:spPr>
-        <p:txBody>
-          <a:bodyPr wrap="square">
-            <a:spAutoFit/>
-          </a:bodyPr>
-          <a:lstStyle/>
-          <a:p>
-            <a:pPr>
-              <a:spcAft>
-                <a:spcPts val="400"/>
-              </a:spcAft>
-              <a:defRPr sz="1200" b="1">
-                <a:solidFill>
-                  <a:srgbClr val="D4AF37"/>
-                </a:solidFill>
-                <a:latin typeface="Georgia"/>
-              </a:defRPr>
-            </a:pPr>
-            <a:r>
-              <a:t>STAGE 3: CONVERSION</a:t>
-            </a:r>
-          </a:p>
-          <a:p>
-            <a:pPr>
-              <a:spcAft>
-                <a:spcPts val="1200"/>
-              </a:spcAft>
-              <a:defRPr sz="1600" b="1">
-                <a:solidFill>
-                  <a:srgbClr val="FFFFFF"/>
-                </a:solidFill>
-                <a:latin typeface="Calibri"/>
-              </a:defRPr>
-            </a:pPr>
-            <a:r>
-              <a:t>Website &amp; WhatsApp</a:t>
-            </a:r>
-          </a:p>
-          <a:p>
-            <a:pPr>
-              <a:defRPr sz="1200">
-                <a:solidFill>
-                  <a:srgbClr val="B4C3D7"/>
-                </a:solidFill>
-                <a:latin typeface="Calibri"/>
-              </a:defRPr>
-            </a:pPr>
-            <a:r>
-              <a:t>Official vetting portal on the website (Tally embed) supported by 1-on-1 WhatsApp VIP concierge consultations.</a:t>
+              <a:t>Alerting invited leaders that 80% of capacity is allocated and parliamentary accreditation requires passport details well in advance.</a:t>
             </a:r>
           </a:p>
         </p:txBody>
@@ -8620,13 +9261,13 @@
               </a:spcAft>
               <a:defRPr sz="1200" b="1">
                 <a:solidFill>
-                  <a:srgbClr val="D4AF37"/>
+                  <a:srgbClr val="FFFFFF"/>
                 </a:solidFill>
                 <a:latin typeface="Georgia"/>
               </a:defRPr>
             </a:pPr>
             <a:r>
-              <a:t>STAGE 4: NURTURING</a:t>
+              <a:t>EMAIL 4: ONBOARDING BRIEFING</a:t>
             </a:r>
           </a:p>
           <a:p>
@@ -8634,7 +9275,7 @@
               <a:spcAft>
                 <a:spcPts val="1200"/>
               </a:spcAft>
-              <a:defRPr sz="1600" b="1">
+              <a:defRPr sz="1500" b="1">
                 <a:solidFill>
                   <a:srgbClr val="FFFFFF"/>
                 </a:solidFill>
@@ -8642,12 +9283,12 @@
               </a:defRPr>
             </a:pPr>
             <a:r>
-              <a:t>Email Drip &amp; App</a:t>
-            </a:r>
-          </a:p>
-          <a:p>
-            <a:pPr>
-              <a:defRPr sz="1200">
+              <a:t>Confirmed Delegate Welcome Package</a:t>
+            </a:r>
+          </a:p>
+          <a:p>
+            <a:pPr>
+              <a:defRPr sz="1150">
                 <a:solidFill>
                   <a:srgbClr val="B4C3D7"/>
                 </a:solidFill>
@@ -8655,7 +9296,7 @@
               </a:defRPr>
             </a:pPr>
             <a:r>
-              <a:t>Targeted 4-stage email newsletters, security vetting confirmations, and digital mobile pass activation.</a:t>
+              <a:t>Dispatched to confirmed leaders with dress codes (Black Tie / Formal), security clearance confirmations, and mobile app download credentials.</a:t>
             </a:r>
           </a:p>
         </p:txBody>

</xml_diff>